<commit_message>
Fix presentation layout, verified against rendered slides
preview.py now also drives PowerPoint, so the deck can be inspected the same
way as the report. Three defects were found and fixed:

- Setting only width/height on a placeholder that inherits its position from
  the layout discards that position. Slide 8's bullets landed above the title
  and slide 11's placeholder collapsed to one character wide. Geometry is now
  pinned explicitly on every resized shape.
- Slide 7's objectives overflowed into the SDG caption, which itself ran
  behind the template's SDG and TRL images. Caption now sits above the two
  images, which are scaled and placed side by side.
- Slide 14's reference block started level with the title and overlapped it.

Co-Authored-By: Claude Opus 5 <noreply@anthropic.com>
</commit_message>
<xml_diff>
--- a/report/Review_3_Team_20106UG02.pptx
+++ b/report/Review_3_Team_20106UG02.pptx
@@ -4408,7 +4408,8 @@
         </p:nvSpPr>
         <p:spPr>
           <a:xfrm>
-            <a:ext cx="0" cy="1920240"/>
+            <a:off x="841248" y="1371600"/>
+            <a:ext cx="10515600" cy="2057400"/>
           </a:xfrm>
         </p:spPr>
         <p:txBody>
@@ -4660,7 +4661,7 @@
         </p:blipFill>
         <p:spPr>
           <a:xfrm>
-            <a:off x="3078480" y="3886200"/>
+            <a:off x="3078480" y="3566160"/>
             <a:ext cx="6035040" cy="2462551"/>
           </a:xfrm>
           <a:prstGeom prst="rect">
@@ -5358,8 +5359,8 @@
         </p:nvSpPr>
         <p:spPr bwMode="auto">
           <a:xfrm>
-            <a:off x="545592" y="1442399"/>
-            <a:ext cx="10515600" cy="1938992"/>
+            <a:off x="640080" y="1325880"/>
+            <a:ext cx="10881360" cy="4754880"/>
           </a:xfrm>
           <a:prstGeom prst="rect">
             <a:avLst/>
@@ -7223,7 +7224,12 @@
             <p:ph idx="1"/>
           </p:nvPr>
         </p:nvSpPr>
-        <p:spPr/>
+        <p:spPr>
+          <a:xfrm>
+            <a:off x="841248" y="1280160"/>
+            <a:ext cx="10515600" cy="2697480"/>
+          </a:xfrm>
+        </p:spPr>
         <p:txBody>
           <a:bodyPr wrap="square">
             <a:normAutofit/>
@@ -7232,14 +7238,14 @@
           <a:p>
             <a:pPr>
               <a:lnSpc>
-                <a:spcPct val="100000"/>
+                <a:spcPct val="95000"/>
               </a:lnSpc>
               <a:spcAft>
                 <a:spcPts val="600"/>
               </a:spcAft>
             </a:pPr>
             <a:r>
-              <a:rPr sz="1400" b="0">
+              <a:rPr sz="1300" b="0">
                 <a:solidFill>
                   <a:srgbClr val="1A1A1A"/>
                 </a:solidFill>
@@ -7250,14 +7256,14 @@
           <a:p>
             <a:pPr>
               <a:lnSpc>
-                <a:spcPct val="100000"/>
+                <a:spcPct val="95000"/>
               </a:lnSpc>
               <a:spcAft>
                 <a:spcPts val="600"/>
               </a:spcAft>
             </a:pPr>
             <a:r>
-              <a:rPr sz="1400" b="0">
+              <a:rPr sz="1300" b="0">
                 <a:solidFill>
                   <a:srgbClr val="1A1A1A"/>
                 </a:solidFill>
@@ -7268,14 +7274,14 @@
           <a:p>
             <a:pPr>
               <a:lnSpc>
-                <a:spcPct val="100000"/>
+                <a:spcPct val="95000"/>
               </a:lnSpc>
               <a:spcAft>
                 <a:spcPts val="600"/>
               </a:spcAft>
             </a:pPr>
             <a:r>
-              <a:rPr sz="1400" b="0">
+              <a:rPr sz="1300" b="0">
                 <a:solidFill>
                   <a:srgbClr val="1A1A1A"/>
                 </a:solidFill>
@@ -7286,14 +7292,14 @@
           <a:p>
             <a:pPr>
               <a:lnSpc>
-                <a:spcPct val="100000"/>
+                <a:spcPct val="95000"/>
               </a:lnSpc>
               <a:spcAft>
                 <a:spcPts val="600"/>
               </a:spcAft>
             </a:pPr>
             <a:r>
-              <a:rPr sz="1400" b="0">
+              <a:rPr sz="1300" b="0">
                 <a:solidFill>
                   <a:srgbClr val="1A1A1A"/>
                 </a:solidFill>
@@ -7304,14 +7310,14 @@
           <a:p>
             <a:pPr>
               <a:lnSpc>
-                <a:spcPct val="100000"/>
+                <a:spcPct val="95000"/>
               </a:lnSpc>
               <a:spcAft>
                 <a:spcPts val="600"/>
               </a:spcAft>
             </a:pPr>
             <a:r>
-              <a:rPr sz="1400" b="0">
+              <a:rPr sz="1300" b="0">
                 <a:solidFill>
                   <a:srgbClr val="1A1A1A"/>
                 </a:solidFill>
@@ -7322,14 +7328,14 @@
           <a:p>
             <a:pPr>
               <a:lnSpc>
-                <a:spcPct val="100000"/>
+                <a:spcPct val="95000"/>
               </a:lnSpc>
               <a:spcAft>
                 <a:spcPts val="600"/>
               </a:spcAft>
             </a:pPr>
             <a:r>
-              <a:rPr sz="1400" b="0">
+              <a:rPr sz="1300" b="0">
                 <a:solidFill>
                   <a:srgbClr val="1A1A1A"/>
                 </a:solidFill>
@@ -7340,14 +7346,14 @@
           <a:p>
             <a:pPr>
               <a:lnSpc>
-                <a:spcPct val="100000"/>
+                <a:spcPct val="95000"/>
               </a:lnSpc>
               <a:spcAft>
                 <a:spcPts val="600"/>
               </a:spcAft>
             </a:pPr>
             <a:r>
-              <a:rPr sz="1400" b="0">
+              <a:rPr sz="1300" b="0">
                 <a:solidFill>
                   <a:srgbClr val="1A1A1A"/>
                 </a:solidFill>
@@ -7525,8 +7531,8 @@
         </p:nvSpPr>
         <p:spPr>
           <a:xfrm>
-            <a:off x="460248" y="4413148"/>
-            <a:ext cx="11523407" cy="892552"/>
+            <a:off x="548640" y="4069080"/>
+            <a:ext cx="11064240" cy="777240"/>
           </a:xfrm>
           <a:prstGeom prst="rect">
             <a:avLst/>
@@ -7541,14 +7547,14 @@
           <a:p>
             <a:pPr>
               <a:lnSpc>
-                <a:spcPct val="100000"/>
+                <a:spcPct val="95000"/>
               </a:lnSpc>
               <a:spcAft>
                 <a:spcPts val="600"/>
               </a:spcAft>
             </a:pPr>
             <a:r>
-              <a:rPr sz="1200" b="1">
+              <a:rPr sz="1150" b="1">
                 <a:solidFill>
                   <a:srgbClr val="1A1A1A"/>
                 </a:solidFill>
@@ -7559,19 +7565,19 @@
           <a:p>
             <a:pPr>
               <a:lnSpc>
-                <a:spcPct val="100000"/>
+                <a:spcPct val="95000"/>
               </a:lnSpc>
               <a:spcAft>
                 <a:spcPts val="600"/>
               </a:spcAft>
             </a:pPr>
             <a:r>
-              <a:rPr sz="1200" b="1">
+              <a:rPr sz="1150" b="1">
                 <a:solidFill>
                   <a:srgbClr val="1A1A1A"/>
                 </a:solidFill>
               </a:rPr>
-              <a:t>Outcome: Conference (Scopus) — paper drafted, target venue to be finalised</a:t>
+              <a:t>Outcome: Conference (Scopus) — paper drafted, target venue to be finalised with the guide</a:t>
             </a:r>
           </a:p>
         </p:txBody>
@@ -7598,8 +7604,8 @@
         </p:blipFill>
         <p:spPr>
           <a:xfrm>
-            <a:off x="1990701" y="4778273"/>
-            <a:ext cx="1968651" cy="1578077"/>
+            <a:off x="3246120" y="4864608"/>
+            <a:ext cx="1654035" cy="1325880"/>
           </a:xfrm>
           <a:prstGeom prst="rect">
             <a:avLst/>
@@ -7628,8 +7634,8 @@
         </p:blipFill>
         <p:spPr>
           <a:xfrm>
-            <a:off x="5237545" y="4413148"/>
-            <a:ext cx="2447027" cy="2232651"/>
+            <a:off x="7086600" y="4864608"/>
+            <a:ext cx="1453189" cy="1325880"/>
           </a:xfrm>
           <a:prstGeom prst="rect">
             <a:avLst/>
@@ -7690,7 +7696,8 @@
         </p:nvSpPr>
         <p:spPr>
           <a:xfrm>
-            <a:ext cx="10515600" cy="731520"/>
+            <a:off x="841248" y="1371600"/>
+            <a:ext cx="10515600" cy="777240"/>
           </a:xfrm>
         </p:spPr>
         <p:txBody>
@@ -7888,7 +7895,7 @@
         </p:blipFill>
         <p:spPr>
           <a:xfrm>
-            <a:off x="2895600" y="2331720"/>
+            <a:off x="2895600" y="2240280"/>
             <a:ext cx="6400800" cy="4036673"/>
           </a:xfrm>
           <a:prstGeom prst="rect">

</xml_diff>

<commit_message>
Follow the template format on the literature review and reference slides
Rendering the blank template showed two prescribed formats I had not followed:

- Slide 5 supplies a picture of an empty five-column table (Paper, Objective,
  Methodology, Pros/Cons, Findings) for the team to replace. I had deleted it
  and written bullets instead. There is now a real banded table in that
  format, with five sources, and the "not more than 2 slides" instruction
  image is removed.
- Slide 14's sample is plain IEEE entries in serif with italicised
  publication titles, not bullets. All eleven references now follow it.

Also fixes a corruption: appending <a:buNone/> to a paragraph that already
had one produced a deck PowerPoint refused to open. Existing bullet elements
are now cleared first, and preview output is no longer suppressed, which is
what hid the failure.

Co-Authored-By: Claude Opus 5 <noreply@anthropic.com>
</commit_message>
<xml_diff>
--- a/report/Review_3_Team_20106UG02.pptx
+++ b/report/Review_3_Team_20106UG02.pptx
@@ -5359,8 +5359,8 @@
         </p:nvSpPr>
         <p:spPr bwMode="auto">
           <a:xfrm>
-            <a:off x="640080" y="1325880"/>
-            <a:ext cx="10881360" cy="4754880"/>
+            <a:off x="640080" y="1298448"/>
+            <a:ext cx="10881360" cy="4846320"/>
           </a:xfrm>
           <a:prstGeom prst="rect">
             <a:avLst/>
@@ -5410,93 +5410,174 @@
           <a:p>
             <a:pPr marL="0" indent="0" eaLnBrk="0" fontAlgn="base" hangingPunct="0">
               <a:lnSpc>
-                <a:spcPct val="100000"/>
+                <a:spcPct val="95000"/>
               </a:lnSpc>
               <a:spcBef>
                 <a:spcPct val="0"/>
               </a:spcBef>
               <a:spcAft>
-                <a:spcPts val="600"/>
+                <a:spcPts val="500"/>
               </a:spcAft>
               <a:buNone/>
             </a:pPr>
             <a:r>
-              <a:rPr sz="1100" b="0">
+              <a:rPr sz="1050" i="0">
                 <a:solidFill>
                   <a:srgbClr val="1A1A1A"/>
                 </a:solidFill>
-              </a:rPr>
-              <a:t>[1] National Institute of Standards and Technology, Module-Lattice-Based Key-Encapsulation Mechanism Standard, FIPS 203, Gaithersburg, MD, USA, Aug. 2024.</a:t>
+                <a:latin typeface="Times New Roman"/>
+              </a:rPr>
+              <a:t>[1] National Institute of Standards and Technology, </a:t>
+            </a:r>
+            <a:r>
+              <a:rPr sz="1050" i="1">
+                <a:solidFill>
+                  <a:srgbClr val="1A1A1A"/>
+                </a:solidFill>
+                <a:latin typeface="Times New Roman"/>
+              </a:rPr>
+              <a:t>Module-Lattice-Based Key-Encapsulation Mechanism Standard</a:t>
+            </a:r>
+            <a:r>
+              <a:rPr sz="1050" i="0">
+                <a:solidFill>
+                  <a:srgbClr val="1A1A1A"/>
+                </a:solidFill>
+                <a:latin typeface="Times New Roman"/>
+              </a:rPr>
+              <a:t>, FIPS 203, Gaithersburg, MD, USA, Aug. 2024.</a:t>
             </a:r>
           </a:p>
           <a:p>
             <a:pPr>
               <a:lnSpc>
-                <a:spcPct val="100000"/>
+                <a:spcPct val="95000"/>
               </a:lnSpc>
               <a:spcAft>
-                <a:spcPts val="600"/>
+                <a:spcPts val="500"/>
               </a:spcAft>
+              <a:buNone/>
             </a:pPr>
             <a:r>
-              <a:rPr sz="1100" b="0">
+              <a:rPr sz="1050" i="0">
                 <a:solidFill>
                   <a:srgbClr val="1A1A1A"/>
                 </a:solidFill>
-              </a:rPr>
-              <a:t>[2] National Institute of Standards and Technology, Module-Lattice-Based Digital Signature Standard, FIPS 204, Gaithersburg, MD, USA, Aug. 2024.</a:t>
+                <a:latin typeface="Times New Roman"/>
+              </a:rPr>
+              <a:t>[2] National Institute of Standards and Technology, </a:t>
+            </a:r>
+            <a:r>
+              <a:rPr sz="1050" i="1">
+                <a:solidFill>
+                  <a:srgbClr val="1A1A1A"/>
+                </a:solidFill>
+                <a:latin typeface="Times New Roman"/>
+              </a:rPr>
+              <a:t>Module-Lattice-Based Digital Signature Standard</a:t>
+            </a:r>
+            <a:r>
+              <a:rPr sz="1050" i="0">
+                <a:solidFill>
+                  <a:srgbClr val="1A1A1A"/>
+                </a:solidFill>
+                <a:latin typeface="Times New Roman"/>
+              </a:rPr>
+              <a:t>, FIPS 204, Gaithersburg, MD, USA, Aug. 2024.</a:t>
             </a:r>
           </a:p>
           <a:p>
             <a:pPr>
               <a:lnSpc>
-                <a:spcPct val="100000"/>
+                <a:spcPct val="95000"/>
               </a:lnSpc>
               <a:spcAft>
-                <a:spcPts val="600"/>
+                <a:spcPts val="500"/>
               </a:spcAft>
+              <a:buNone/>
             </a:pPr>
             <a:r>
-              <a:rPr sz="1100" b="0">
+              <a:rPr sz="1050" i="0">
                 <a:solidFill>
                   <a:srgbClr val="1A1A1A"/>
                 </a:solidFill>
-              </a:rPr>
-              <a:t>[3] National Institute of Standards and Technology, Stateless Hash-Based Digital Signature Standard, FIPS 205, Gaithersburg, MD, USA, Aug. 2024.</a:t>
+                <a:latin typeface="Times New Roman"/>
+              </a:rPr>
+              <a:t>[3] National Institute of Standards and Technology, </a:t>
+            </a:r>
+            <a:r>
+              <a:rPr sz="1050" i="1">
+                <a:solidFill>
+                  <a:srgbClr val="1A1A1A"/>
+                </a:solidFill>
+                <a:latin typeface="Times New Roman"/>
+              </a:rPr>
+              <a:t>Stateless Hash-Based Digital Signature Standard</a:t>
+            </a:r>
+            <a:r>
+              <a:rPr sz="1050" i="0">
+                <a:solidFill>
+                  <a:srgbClr val="1A1A1A"/>
+                </a:solidFill>
+                <a:latin typeface="Times New Roman"/>
+              </a:rPr>
+              <a:t>, FIPS 205, Gaithersburg, MD, USA, Aug. 2024.</a:t>
             </a:r>
           </a:p>
           <a:p>
             <a:pPr>
               <a:lnSpc>
-                <a:spcPct val="100000"/>
+                <a:spcPct val="95000"/>
               </a:lnSpc>
               <a:spcAft>
-                <a:spcPts val="600"/>
+                <a:spcPts val="500"/>
               </a:spcAft>
+              <a:buNone/>
             </a:pPr>
             <a:r>
-              <a:rPr sz="1100" b="0">
+              <a:rPr sz="1050" i="0">
                 <a:solidFill>
                   <a:srgbClr val="1A1A1A"/>
                 </a:solidFill>
-              </a:rPr>
-              <a:t>[4] National Cybersecurity Center of Excellence, Migration to Post-Quantum Cryptography, NIST Special Publication 1800-38, National Institute of Standards and Technology.</a:t>
+                <a:latin typeface="Times New Roman"/>
+              </a:rPr>
+              <a:t>[4] National Cybersecurity Center of Excellence, </a:t>
+            </a:r>
+            <a:r>
+              <a:rPr sz="1050" i="1">
+                <a:solidFill>
+                  <a:srgbClr val="1A1A1A"/>
+                </a:solidFill>
+                <a:latin typeface="Times New Roman"/>
+              </a:rPr>
+              <a:t>Migration to Post-Quantum Cryptography</a:t>
+            </a:r>
+            <a:r>
+              <a:rPr sz="1050" i="0">
+                <a:solidFill>
+                  <a:srgbClr val="1A1A1A"/>
+                </a:solidFill>
+                <a:latin typeface="Times New Roman"/>
+              </a:rPr>
+              <a:t>, NIST Special Publication 1800-38, Gaithersburg, MD, USA.</a:t>
             </a:r>
           </a:p>
           <a:p>
             <a:pPr>
               <a:lnSpc>
-                <a:spcPct val="100000"/>
+                <a:spcPct val="95000"/>
               </a:lnSpc>
               <a:spcAft>
-                <a:spcPts val="600"/>
+                <a:spcPts val="500"/>
               </a:spcAft>
+              <a:buNone/>
             </a:pPr>
             <a:r>
-              <a:rPr sz="1100" b="0">
+              <a:rPr sz="1050" i="0">
                 <a:solidFill>
                   <a:srgbClr val="1A1A1A"/>
                 </a:solidFill>
+                <a:latin typeface="Times New Roman"/>
               </a:rPr>
               <a:t>[5] G. Pope, “kyber-py: A pure-Python implementation of ML-KEM (FIPS 203),” software repository, version 1.2.0.</a:t>
             </a:r>
@@ -5504,17 +5585,19 @@
           <a:p>
             <a:pPr>
               <a:lnSpc>
-                <a:spcPct val="100000"/>
+                <a:spcPct val="95000"/>
               </a:lnSpc>
               <a:spcAft>
-                <a:spcPts val="600"/>
+                <a:spcPts val="500"/>
               </a:spcAft>
+              <a:buNone/>
             </a:pPr>
             <a:r>
-              <a:rPr sz="1100" b="0">
+              <a:rPr sz="1050" i="0">
                 <a:solidFill>
                   <a:srgbClr val="1A1A1A"/>
                 </a:solidFill>
+                <a:latin typeface="Times New Roman"/>
               </a:rPr>
               <a:t>[6] G. Pope, “dilithium-py: A pure-Python implementation of ML-DSA (FIPS 204),” software repository, version 1.4.0.</a:t>
             </a:r>
@@ -5522,37 +5605,191 @@
           <a:p>
             <a:pPr>
               <a:lnSpc>
-                <a:spcPct val="100000"/>
+                <a:spcPct val="95000"/>
               </a:lnSpc>
               <a:spcAft>
-                <a:spcPts val="600"/>
+                <a:spcPts val="500"/>
               </a:spcAft>
+              <a:buNone/>
             </a:pPr>
             <a:r>
-              <a:rPr sz="1100" b="0">
+              <a:rPr sz="1050" i="0">
                 <a:solidFill>
                   <a:srgbClr val="1A1A1A"/>
                 </a:solidFill>
-              </a:rPr>
-              <a:t>[7] W. Barker, W. Polk and M. Souppaya, Getting Ready for Post-Quantum Cryptography: Exploring Challenges Associated with Adopting and Using Post-Quantum Cryptographic Algorithms, NIST Cybersecurity White Paper, 2021.</a:t>
+                <a:latin typeface="Times New Roman"/>
+              </a:rPr>
+              <a:t>[7] W. Barker, W. Polk and M. Souppaya, </a:t>
+            </a:r>
+            <a:r>
+              <a:rPr sz="1050" i="1">
+                <a:solidFill>
+                  <a:srgbClr val="1A1A1A"/>
+                </a:solidFill>
+                <a:latin typeface="Times New Roman"/>
+              </a:rPr>
+              <a:t>Getting Ready for Post-Quantum Cryptography</a:t>
+            </a:r>
+            <a:r>
+              <a:rPr sz="1050" i="0">
+                <a:solidFill>
+                  <a:srgbClr val="1A1A1A"/>
+                </a:solidFill>
+                <a:latin typeface="Times New Roman"/>
+              </a:rPr>
+              <a:t>, NIST Cybersecurity White Paper, 2021.</a:t>
             </a:r>
           </a:p>
           <a:p>
             <a:pPr>
               <a:lnSpc>
-                <a:spcPct val="100000"/>
+                <a:spcPct val="95000"/>
               </a:lnSpc>
               <a:spcAft>
-                <a:spcPts val="600"/>
+                <a:spcPts val="500"/>
               </a:spcAft>
+              <a:buNone/>
             </a:pPr>
             <a:r>
-              <a:rPr sz="1100" b="0">
+              <a:rPr sz="1050" i="0">
                 <a:solidFill>
                   <a:srgbClr val="1A1A1A"/>
                 </a:solidFill>
-              </a:rPr>
-              <a:t>[8] M. Chen et al., “Evaluating large language models trained on code,” arXiv preprint arXiv:2107.03374, 2021.</a:t>
+                <a:latin typeface="Times New Roman"/>
+              </a:rPr>
+              <a:t>[8] M. Chen et al., “Evaluating large language models trained on code,” </a:t>
+            </a:r>
+            <a:r>
+              <a:rPr sz="1050" i="1">
+                <a:solidFill>
+                  <a:srgbClr val="1A1A1A"/>
+                </a:solidFill>
+                <a:latin typeface="Times New Roman"/>
+              </a:rPr>
+              <a:t>arXiv preprint</a:t>
+            </a:r>
+            <a:r>
+              <a:rPr sz="1050" i="0">
+                <a:solidFill>
+                  <a:srgbClr val="1A1A1A"/>
+                </a:solidFill>
+                <a:latin typeface="Times New Roman"/>
+              </a:rPr>
+              <a:t> arXiv:2107.03374, 2021.</a:t>
+            </a:r>
+          </a:p>
+          <a:p>
+            <a:pPr>
+              <a:lnSpc>
+                <a:spcPct val="95000"/>
+              </a:lnSpc>
+              <a:spcAft>
+                <a:spcPts val="500"/>
+              </a:spcAft>
+              <a:buNone/>
+            </a:pPr>
+            <a:r>
+              <a:rPr sz="1050" i="0">
+                <a:solidFill>
+                  <a:srgbClr val="1A1A1A"/>
+                </a:solidFill>
+                <a:latin typeface="Times New Roman"/>
+              </a:rPr>
+              <a:t>[9] M. Mosca, “Cybersecurity in an era with quantum computers: Will we be ready?,” </a:t>
+            </a:r>
+            <a:r>
+              <a:rPr sz="1050" i="1">
+                <a:solidFill>
+                  <a:srgbClr val="1A1A1A"/>
+                </a:solidFill>
+                <a:latin typeface="Times New Roman"/>
+              </a:rPr>
+              <a:t>IEEE Security &amp; Privacy</a:t>
+            </a:r>
+            <a:r>
+              <a:rPr sz="1050" i="0">
+                <a:solidFill>
+                  <a:srgbClr val="1A1A1A"/>
+                </a:solidFill>
+                <a:latin typeface="Times New Roman"/>
+              </a:rPr>
+              <a:t>, vol. 16, no. 5, pp. 38-41, 2018.</a:t>
+            </a:r>
+          </a:p>
+          <a:p>
+            <a:pPr>
+              <a:lnSpc>
+                <a:spcPct val="95000"/>
+              </a:lnSpc>
+              <a:spcAft>
+                <a:spcPts val="500"/>
+              </a:spcAft>
+              <a:buNone/>
+            </a:pPr>
+            <a:r>
+              <a:rPr sz="1050" i="0">
+                <a:solidFill>
+                  <a:srgbClr val="1A1A1A"/>
+                </a:solidFill>
+                <a:latin typeface="Times New Roman"/>
+              </a:rPr>
+              <a:t>[10] D. Stebila and M. Mosca, “Post-quantum key exchange for the Internet and the Open Quantum Safe project,” in </a:t>
+            </a:r>
+            <a:r>
+              <a:rPr sz="1050" i="1">
+                <a:solidFill>
+                  <a:srgbClr val="1A1A1A"/>
+                </a:solidFill>
+                <a:latin typeface="Times New Roman"/>
+              </a:rPr>
+              <a:t>Proc. Selected Areas in Cryptography (SAC 2016)</a:t>
+            </a:r>
+            <a:r>
+              <a:rPr sz="1050" i="0">
+                <a:solidFill>
+                  <a:srgbClr val="1A1A1A"/>
+                </a:solidFill>
+                <a:latin typeface="Times New Roman"/>
+              </a:rPr>
+              <a:t>, LNCS vol. 10532, pp. 14-37.</a:t>
+            </a:r>
+          </a:p>
+          <a:p>
+            <a:pPr>
+              <a:lnSpc>
+                <a:spcPct val="95000"/>
+              </a:lnSpc>
+              <a:spcAft>
+                <a:spcPts val="500"/>
+              </a:spcAft>
+              <a:buNone/>
+            </a:pPr>
+            <a:r>
+              <a:rPr sz="1050" i="0">
+                <a:solidFill>
+                  <a:srgbClr val="1A1A1A"/>
+                </a:solidFill>
+                <a:latin typeface="Times New Roman"/>
+              </a:rPr>
+              <a:t>[11] P. W. Shor, “Polynomial-time algorithms for prime factorization and discrete logarithms on a quantum computer,” </a:t>
+            </a:r>
+            <a:r>
+              <a:rPr sz="1050" i="1">
+                <a:solidFill>
+                  <a:srgbClr val="1A1A1A"/>
+                </a:solidFill>
+                <a:latin typeface="Times New Roman"/>
+              </a:rPr>
+              <a:t>SIAM Journal on Computing</a:t>
+            </a:r>
+            <a:r>
+              <a:rPr sz="1050" i="0">
+                <a:solidFill>
+                  <a:srgbClr val="1A1A1A"/>
+                </a:solidFill>
+                <a:latin typeface="Times New Roman"/>
+              </a:rPr>
+              <a:t>, vol. 26, no. 5, pp. 1484-1509, 1997.</a:t>
             </a:r>
           </a:p>
         </p:txBody>
@@ -6654,36 +6891,6 @@
           </a:p>
         </p:txBody>
       </p:sp>
-      <p:pic>
-        <p:nvPicPr>
-          <p:cNvPr id="7" name="Picture 6">
-            <a:extLst>
-              <a:ext uri="{FF2B5EF4-FFF2-40B4-BE49-F238E27FC236}">
-                <a16:creationId xmlns:a16="http://schemas.microsoft.com/office/drawing/2014/main" xmlns="" id="{2EB6993A-B8FB-1E92-71D4-98155A7EDC1C}"/>
-              </a:ext>
-            </a:extLst>
-          </p:cNvPr>
-          <p:cNvPicPr>
-            <a:picLocks noChangeAspect="1"/>
-          </p:cNvPicPr>
-          <p:nvPr/>
-        </p:nvPicPr>
-        <p:blipFill>
-          <a:blip r:embed="rId3"/>
-          <a:stretch>
-            <a:fillRect/>
-          </a:stretch>
-        </p:blipFill>
-        <p:spPr>
-          <a:xfrm>
-            <a:off x="636858" y="4611603"/>
-            <a:ext cx="4017612" cy="487722"/>
-          </a:xfrm>
-          <a:prstGeom prst="rect">
-            <a:avLst/>
-          </a:prstGeom>
-        </p:spPr>
-      </p:pic>
       <p:sp>
         <p:nvSpPr>
           <p:cNvPr id="8" name="Date Placeholder 7">
@@ -6770,101 +6977,902 @@
           </a:p>
         </p:txBody>
       </p:sp>
-      <p:sp>
-        <p:nvSpPr>
-          <p:cNvPr id="11" name="TextBox 10"/>
-          <p:cNvSpPr txBox="1"/>
+      <p:graphicFrame>
+        <p:nvGraphicFramePr>
+          <p:cNvPr id="11" name="Table 10"/>
+          <p:cNvGraphicFramePr>
+            <a:graphicFrameLocks noGrp="1"/>
+          </p:cNvGraphicFramePr>
           <p:nvPr/>
-        </p:nvSpPr>
-        <p:spPr>
-          <a:xfrm>
-            <a:off x="841248" y="1417320"/>
-            <a:ext cx="10515600" cy="2926080"/>
-          </a:xfrm>
-          <a:prstGeom prst="rect">
-            <a:avLst/>
-          </a:prstGeom>
-          <a:noFill/>
-        </p:spPr>
-        <p:txBody>
-          <a:bodyPr wrap="square">
-            <a:spAutoFit/>
-          </a:bodyPr>
-          <a:lstStyle/>
-          <a:p>
-            <a:pPr>
-              <a:lnSpc>
-                <a:spcPct val="100000"/>
-              </a:lnSpc>
-              <a:spcAft>
-                <a:spcPts val="600"/>
-              </a:spcAft>
-            </a:pPr>
-            <a:r>
-              <a:rPr sz="1500" b="0">
-                <a:solidFill>
-                  <a:srgbClr val="1A1A1A"/>
-                </a:solidFill>
-              </a:rPr>
-              <a:t>Cryptographic discovery — NCCoE SP 1800-38: inventory is the first step, but stops at a catalogue; no recommendation, no code change.</a:t>
-            </a:r>
-          </a:p>
-          <a:p>
-            <a:pPr>
-              <a:lnSpc>
-                <a:spcPct val="100000"/>
-              </a:lnSpc>
-              <a:spcAft>
-                <a:spcPts val="600"/>
-              </a:spcAft>
-            </a:pPr>
-            <a:r>
-              <a:rPr sz="1500" b="0">
-                <a:solidFill>
-                  <a:srgbClr val="1A1A1A"/>
-                </a:solidFill>
-              </a:rPr>
-              <a:t>Standards and guidance — FIPS 203/204/205 and NIST white papers define the destination and crypto-agility, not a path for existing code.</a:t>
-            </a:r>
-          </a:p>
-          <a:p>
-            <a:pPr>
-              <a:lnSpc>
-                <a:spcPct val="100000"/>
-              </a:lnSpc>
-              <a:spcAft>
-                <a:spcPts val="600"/>
-              </a:spcAft>
-            </a:pPr>
-            <a:r>
-              <a:rPr sz="1500" b="0">
-                <a:solidFill>
-                  <a:srgbClr val="1A1A1A"/>
-                </a:solidFill>
-              </a:rPr>
-              <a:t>PQC implementations — liboqs, kyber-py, dilithium-py supply the primitives but do not migrate anything.</a:t>
-            </a:r>
-          </a:p>
-          <a:p>
-            <a:pPr>
-              <a:lnSpc>
-                <a:spcPct val="100000"/>
-              </a:lnSpc>
-              <a:spcAft>
-                <a:spcPts val="600"/>
-              </a:spcAft>
-            </a:pPr>
-            <a:r>
-              <a:rPr sz="1500" b="0">
-                <a:solidFill>
-                  <a:srgbClr val="1A1A1A"/>
-                </a:solidFill>
-              </a:rPr>
-              <a:t>LLM code transformation — promising on isolated functions, but output always requires human verification before it can be trusted.</a:t>
-            </a:r>
-          </a:p>
-        </p:txBody>
-      </p:sp>
+        </p:nvGraphicFramePr>
+        <p:xfrm>
+          <a:off x="384048" y="1325880"/>
+          <a:ext cx="11430000" cy="4754880"/>
+        </p:xfrm>
+        <a:graphic>
+          <a:graphicData uri="http://schemas.openxmlformats.org/drawingml/2006/table">
+            <a:tbl>
+              <a:tblPr firstRow="1">
+                <a:tableStyleId>{5C22544A-7EE6-4342-B048-85BDC9FD1C3A}</a:tableStyleId>
+              </a:tblPr>
+              <a:tblGrid>
+                <a:gridCol w="2057400"/>
+                <a:gridCol w="2057400"/>
+                <a:gridCol w="2240280"/>
+                <a:gridCol w="2514600"/>
+                <a:gridCol w="2560320"/>
+              </a:tblGrid>
+              <a:tr h="792480">
+                <a:tc>
+                  <a:txBody>
+                    <a:bodyPr wrap="square"/>
+                    <a:lstStyle/>
+                    <a:p>
+                      <a:pPr>
+                        <a:lnSpc>
+                          <a:spcPct val="92000"/>
+                        </a:lnSpc>
+                      </a:pPr>
+                      <a:r>
+                        <a:rPr sz="1200" b="1">
+                          <a:solidFill>
+                            <a:srgbClr val="FFFFFF"/>
+                          </a:solidFill>
+                        </a:rPr>
+                        <a:t>Paper / Source</a:t>
+                      </a:r>
+                    </a:p>
+                  </a:txBody>
+                  <a:tcPr marL="64008" marR="64008" marT="27432" marB="27432">
+                    <a:solidFill>
+                      <a:srgbClr val="4472C4"/>
+                    </a:solidFill>
+                  </a:tcPr>
+                </a:tc>
+                <a:tc>
+                  <a:txBody>
+                    <a:bodyPr wrap="square"/>
+                    <a:lstStyle/>
+                    <a:p>
+                      <a:pPr>
+                        <a:lnSpc>
+                          <a:spcPct val="92000"/>
+                        </a:lnSpc>
+                      </a:pPr>
+                      <a:r>
+                        <a:rPr sz="1200" b="1">
+                          <a:solidFill>
+                            <a:srgbClr val="FFFFFF"/>
+                          </a:solidFill>
+                        </a:rPr>
+                        <a:t>Objective</a:t>
+                      </a:r>
+                    </a:p>
+                  </a:txBody>
+                  <a:tcPr marL="64008" marR="64008" marT="27432" marB="27432">
+                    <a:solidFill>
+                      <a:srgbClr val="4472C4"/>
+                    </a:solidFill>
+                  </a:tcPr>
+                </a:tc>
+                <a:tc>
+                  <a:txBody>
+                    <a:bodyPr wrap="square"/>
+                    <a:lstStyle/>
+                    <a:p>
+                      <a:pPr>
+                        <a:lnSpc>
+                          <a:spcPct val="92000"/>
+                        </a:lnSpc>
+                      </a:pPr>
+                      <a:r>
+                        <a:rPr sz="1200" b="1">
+                          <a:solidFill>
+                            <a:srgbClr val="FFFFFF"/>
+                          </a:solidFill>
+                        </a:rPr>
+                        <a:t>Methodology</a:t>
+                      </a:r>
+                    </a:p>
+                  </a:txBody>
+                  <a:tcPr marL="64008" marR="64008" marT="27432" marB="27432">
+                    <a:solidFill>
+                      <a:srgbClr val="4472C4"/>
+                    </a:solidFill>
+                  </a:tcPr>
+                </a:tc>
+                <a:tc>
+                  <a:txBody>
+                    <a:bodyPr wrap="square"/>
+                    <a:lstStyle/>
+                    <a:p>
+                      <a:pPr>
+                        <a:lnSpc>
+                          <a:spcPct val="92000"/>
+                        </a:lnSpc>
+                      </a:pPr>
+                      <a:r>
+                        <a:rPr sz="1200" b="1">
+                          <a:solidFill>
+                            <a:srgbClr val="FFFFFF"/>
+                          </a:solidFill>
+                        </a:rPr>
+                        <a:t>Pros / Cons</a:t>
+                      </a:r>
+                    </a:p>
+                  </a:txBody>
+                  <a:tcPr marL="64008" marR="64008" marT="27432" marB="27432">
+                    <a:solidFill>
+                      <a:srgbClr val="4472C4"/>
+                    </a:solidFill>
+                  </a:tcPr>
+                </a:tc>
+                <a:tc>
+                  <a:txBody>
+                    <a:bodyPr wrap="square"/>
+                    <a:lstStyle/>
+                    <a:p>
+                      <a:pPr>
+                        <a:lnSpc>
+                          <a:spcPct val="92000"/>
+                        </a:lnSpc>
+                      </a:pPr>
+                      <a:r>
+                        <a:rPr sz="1200" b="1">
+                          <a:solidFill>
+                            <a:srgbClr val="FFFFFF"/>
+                          </a:solidFill>
+                        </a:rPr>
+                        <a:t>Findings</a:t>
+                      </a:r>
+                    </a:p>
+                  </a:txBody>
+                  <a:tcPr marL="64008" marR="64008" marT="27432" marB="27432">
+                    <a:solidFill>
+                      <a:srgbClr val="4472C4"/>
+                    </a:solidFill>
+                  </a:tcPr>
+                </a:tc>
+              </a:tr>
+              <a:tr h="792480">
+                <a:tc>
+                  <a:txBody>
+                    <a:bodyPr wrap="square"/>
+                    <a:lstStyle/>
+                    <a:p>
+                      <a:pPr>
+                        <a:lnSpc>
+                          <a:spcPct val="92000"/>
+                        </a:lnSpc>
+                      </a:pPr>
+                      <a:r>
+                        <a:rPr sz="950" b="0">
+                          <a:solidFill>
+                            <a:srgbClr val="1A1A1A"/>
+                          </a:solidFill>
+                        </a:rPr>
+                        <a:t>NIST FIPS 203, 204, 205 (2024)</a:t>
+                      </a:r>
+                    </a:p>
+                  </a:txBody>
+                  <a:tcPr marL="64008" marR="64008" marT="27432" marB="27432">
+                    <a:solidFill>
+                      <a:srgbClr val="CCD7EA"/>
+                    </a:solidFill>
+                  </a:tcPr>
+                </a:tc>
+                <a:tc>
+                  <a:txBody>
+                    <a:bodyPr wrap="square"/>
+                    <a:lstStyle/>
+                    <a:p>
+                      <a:pPr>
+                        <a:lnSpc>
+                          <a:spcPct val="92000"/>
+                        </a:lnSpc>
+                      </a:pPr>
+                      <a:r>
+                        <a:rPr sz="950" b="0">
+                          <a:solidFill>
+                            <a:srgbClr val="1A1A1A"/>
+                          </a:solidFill>
+                        </a:rPr>
+                        <a:t>Standardise quantum-resistant KEM and signature schemes</a:t>
+                      </a:r>
+                    </a:p>
+                  </a:txBody>
+                  <a:tcPr marL="64008" marR="64008" marT="27432" marB="27432">
+                    <a:solidFill>
+                      <a:srgbClr val="CCD7EA"/>
+                    </a:solidFill>
+                  </a:tcPr>
+                </a:tc>
+                <a:tc>
+                  <a:txBody>
+                    <a:bodyPr wrap="square"/>
+                    <a:lstStyle/>
+                    <a:p>
+                      <a:pPr>
+                        <a:lnSpc>
+                          <a:spcPct val="92000"/>
+                        </a:lnSpc>
+                      </a:pPr>
+                      <a:r>
+                        <a:rPr sz="950" b="0">
+                          <a:solidFill>
+                            <a:srgbClr val="1A1A1A"/>
+                          </a:solidFill>
+                        </a:rPr>
+                        <a:t>Multi-round public evaluation of lattice and hash-based candidates</a:t>
+                      </a:r>
+                    </a:p>
+                  </a:txBody>
+                  <a:tcPr marL="64008" marR="64008" marT="27432" marB="27432">
+                    <a:solidFill>
+                      <a:srgbClr val="CCD7EA"/>
+                    </a:solidFill>
+                  </a:tcPr>
+                </a:tc>
+                <a:tc>
+                  <a:txBody>
+                    <a:bodyPr wrap="square"/>
+                    <a:lstStyle/>
+                    <a:p>
+                      <a:pPr>
+                        <a:lnSpc>
+                          <a:spcPct val="92000"/>
+                        </a:lnSpc>
+                      </a:pPr>
+                      <a:r>
+                        <a:rPr sz="950" b="0">
+                          <a:solidFill>
+                            <a:srgbClr val="1A1A1A"/>
+                          </a:solidFill>
+                        </a:rPr>
+                        <a:t>Pro: settles which algorithms to adopt.</a:t>
+                      </a:r>
+                    </a:p>
+                    <a:p>
+                      <a:pPr>
+                        <a:lnSpc>
+                          <a:spcPct val="92000"/>
+                        </a:lnSpc>
+                      </a:pPr>
+                      <a:r>
+                        <a:rPr sz="950" b="0">
+                          <a:solidFill>
+                            <a:srgbClr val="1A1A1A"/>
+                          </a:solidFill>
+                        </a:rPr>
+                        <a:t>Con: silent on migrating existing code</a:t>
+                      </a:r>
+                    </a:p>
+                  </a:txBody>
+                  <a:tcPr marL="64008" marR="64008" marT="27432" marB="27432">
+                    <a:solidFill>
+                      <a:srgbClr val="CCD7EA"/>
+                    </a:solidFill>
+                  </a:tcPr>
+                </a:tc>
+                <a:tc>
+                  <a:txBody>
+                    <a:bodyPr wrap="square"/>
+                    <a:lstStyle/>
+                    <a:p>
+                      <a:pPr>
+                        <a:lnSpc>
+                          <a:spcPct val="92000"/>
+                        </a:lnSpc>
+                      </a:pPr>
+                      <a:r>
+                        <a:rPr sz="950" b="0">
+                          <a:solidFill>
+                            <a:srgbClr val="1A1A1A"/>
+                          </a:solidFill>
+                        </a:rPr>
+                        <a:t>ML-KEM, ML-DSA and SLH-DSA with defined parameter sets per security category</a:t>
+                      </a:r>
+                    </a:p>
+                  </a:txBody>
+                  <a:tcPr marL="64008" marR="64008" marT="27432" marB="27432">
+                    <a:solidFill>
+                      <a:srgbClr val="CCD7EA"/>
+                    </a:solidFill>
+                  </a:tcPr>
+                </a:tc>
+              </a:tr>
+              <a:tr h="792480">
+                <a:tc>
+                  <a:txBody>
+                    <a:bodyPr wrap="square"/>
+                    <a:lstStyle/>
+                    <a:p>
+                      <a:pPr>
+                        <a:lnSpc>
+                          <a:spcPct val="92000"/>
+                        </a:lnSpc>
+                      </a:pPr>
+                      <a:r>
+                        <a:rPr sz="950" b="0">
+                          <a:solidFill>
+                            <a:srgbClr val="1A1A1A"/>
+                          </a:solidFill>
+                        </a:rPr>
+                        <a:t>NCCoE, NIST SP 1800-38 — Migration to PQC</a:t>
+                      </a:r>
+                    </a:p>
+                  </a:txBody>
+                  <a:tcPr marL="64008" marR="64008" marT="27432" marB="27432">
+                    <a:solidFill>
+                      <a:srgbClr val="DEE6F2"/>
+                    </a:solidFill>
+                  </a:tcPr>
+                </a:tc>
+                <a:tc>
+                  <a:txBody>
+                    <a:bodyPr wrap="square"/>
+                    <a:lstStyle/>
+                    <a:p>
+                      <a:pPr>
+                        <a:lnSpc>
+                          <a:spcPct val="92000"/>
+                        </a:lnSpc>
+                      </a:pPr>
+                      <a:r>
+                        <a:rPr sz="950" b="0">
+                          <a:solidFill>
+                            <a:srgbClr val="1A1A1A"/>
+                          </a:solidFill>
+                        </a:rPr>
+                        <a:t>Define a migration programme for enterprises</a:t>
+                      </a:r>
+                    </a:p>
+                  </a:txBody>
+                  <a:tcPr marL="64008" marR="64008" marT="27432" marB="27432">
+                    <a:solidFill>
+                      <a:srgbClr val="DEE6F2"/>
+                    </a:solidFill>
+                  </a:tcPr>
+                </a:tc>
+                <a:tc>
+                  <a:txBody>
+                    <a:bodyPr wrap="square"/>
+                    <a:lstStyle/>
+                    <a:p>
+                      <a:pPr>
+                        <a:lnSpc>
+                          <a:spcPct val="92000"/>
+                        </a:lnSpc>
+                      </a:pPr>
+                      <a:r>
+                        <a:rPr sz="950" b="0">
+                          <a:solidFill>
+                            <a:srgbClr val="1A1A1A"/>
+                          </a:solidFill>
+                        </a:rPr>
+                        <a:t>Practice guidance centred on cryptographic discovery and inventory</a:t>
+                      </a:r>
+                    </a:p>
+                  </a:txBody>
+                  <a:tcPr marL="64008" marR="64008" marT="27432" marB="27432">
+                    <a:solidFill>
+                      <a:srgbClr val="DEE6F2"/>
+                    </a:solidFill>
+                  </a:tcPr>
+                </a:tc>
+                <a:tc>
+                  <a:txBody>
+                    <a:bodyPr wrap="square"/>
+                    <a:lstStyle/>
+                    <a:p>
+                      <a:pPr>
+                        <a:lnSpc>
+                          <a:spcPct val="92000"/>
+                        </a:lnSpc>
+                      </a:pPr>
+                      <a:r>
+                        <a:rPr sz="950" b="0">
+                          <a:solidFill>
+                            <a:srgbClr val="1A1A1A"/>
+                          </a:solidFill>
+                        </a:rPr>
+                        <a:t>Pro: establishes discovery as the first step.</a:t>
+                      </a:r>
+                    </a:p>
+                    <a:p>
+                      <a:pPr>
+                        <a:lnSpc>
+                          <a:spcPct val="92000"/>
+                        </a:lnSpc>
+                      </a:pPr>
+                      <a:r>
+                        <a:rPr sz="950" b="0">
+                          <a:solidFill>
+                            <a:srgbClr val="1A1A1A"/>
+                          </a:solidFill>
+                        </a:rPr>
+                        <a:t>Con: produces an inventory only</a:t>
+                      </a:r>
+                    </a:p>
+                  </a:txBody>
+                  <a:tcPr marL="64008" marR="64008" marT="27432" marB="27432">
+                    <a:solidFill>
+                      <a:srgbClr val="DEE6F2"/>
+                    </a:solidFill>
+                  </a:tcPr>
+                </a:tc>
+                <a:tc>
+                  <a:txBody>
+                    <a:bodyPr wrap="square"/>
+                    <a:lstStyle/>
+                    <a:p>
+                      <a:pPr>
+                        <a:lnSpc>
+                          <a:spcPct val="92000"/>
+                        </a:lnSpc>
+                      </a:pPr>
+                      <a:r>
+                        <a:rPr sz="950" b="0">
+                          <a:solidFill>
+                            <a:srgbClr val="1A1A1A"/>
+                          </a:solidFill>
+                        </a:rPr>
+                        <a:t>Knowing where crypto lives does not say what should replace it</a:t>
+                      </a:r>
+                    </a:p>
+                  </a:txBody>
+                  <a:tcPr marL="64008" marR="64008" marT="27432" marB="27432">
+                    <a:solidFill>
+                      <a:srgbClr val="DEE6F2"/>
+                    </a:solidFill>
+                  </a:tcPr>
+                </a:tc>
+              </a:tr>
+              <a:tr h="792480">
+                <a:tc>
+                  <a:txBody>
+                    <a:bodyPr wrap="square"/>
+                    <a:lstStyle/>
+                    <a:p>
+                      <a:pPr>
+                        <a:lnSpc>
+                          <a:spcPct val="92000"/>
+                        </a:lnSpc>
+                      </a:pPr>
+                      <a:r>
+                        <a:rPr sz="950" b="0">
+                          <a:solidFill>
+                            <a:srgbClr val="1A1A1A"/>
+                          </a:solidFill>
+                        </a:rPr>
+                        <a:t>Stebila &amp; Mosca, Open Quantum Safe (SAC 2016); kyber-py, dilithium-py</a:t>
+                      </a:r>
+                    </a:p>
+                  </a:txBody>
+                  <a:tcPr marL="64008" marR="64008" marT="27432" marB="27432">
+                    <a:solidFill>
+                      <a:srgbClr val="CCD7EA"/>
+                    </a:solidFill>
+                  </a:tcPr>
+                </a:tc>
+                <a:tc>
+                  <a:txBody>
+                    <a:bodyPr wrap="square"/>
+                    <a:lstStyle/>
+                    <a:p>
+                      <a:pPr>
+                        <a:lnSpc>
+                          <a:spcPct val="92000"/>
+                        </a:lnSpc>
+                      </a:pPr>
+                      <a:r>
+                        <a:rPr sz="950" b="0">
+                          <a:solidFill>
+                            <a:srgbClr val="1A1A1A"/>
+                          </a:solidFill>
+                        </a:rPr>
+                        <a:t>Make post-quantum primitives usable in real software</a:t>
+                      </a:r>
+                    </a:p>
+                  </a:txBody>
+                  <a:tcPr marL="64008" marR="64008" marT="27432" marB="27432">
+                    <a:solidFill>
+                      <a:srgbClr val="CCD7EA"/>
+                    </a:solidFill>
+                  </a:tcPr>
+                </a:tc>
+                <a:tc>
+                  <a:txBody>
+                    <a:bodyPr wrap="square"/>
+                    <a:lstStyle/>
+                    <a:p>
+                      <a:pPr>
+                        <a:lnSpc>
+                          <a:spcPct val="92000"/>
+                        </a:lnSpc>
+                      </a:pPr>
+                      <a:r>
+                        <a:rPr sz="950" b="0">
+                          <a:solidFill>
+                            <a:srgbClr val="1A1A1A"/>
+                          </a:solidFill>
+                        </a:rPr>
+                        <a:t>Open-source reference and optimised implementations</a:t>
+                      </a:r>
+                    </a:p>
+                  </a:txBody>
+                  <a:tcPr marL="64008" marR="64008" marT="27432" marB="27432">
+                    <a:solidFill>
+                      <a:srgbClr val="CCD7EA"/>
+                    </a:solidFill>
+                  </a:tcPr>
+                </a:tc>
+                <a:tc>
+                  <a:txBody>
+                    <a:bodyPr wrap="square"/>
+                    <a:lstStyle/>
+                    <a:p>
+                      <a:pPr>
+                        <a:lnSpc>
+                          <a:spcPct val="92000"/>
+                        </a:lnSpc>
+                      </a:pPr>
+                      <a:r>
+                        <a:rPr sz="950" b="0">
+                          <a:solidFill>
+                            <a:srgbClr val="1A1A1A"/>
+                          </a:solidFill>
+                        </a:rPr>
+                        <a:t>Pro: production-quality primitives available.</a:t>
+                      </a:r>
+                    </a:p>
+                    <a:p>
+                      <a:pPr>
+                        <a:lnSpc>
+                          <a:spcPct val="92000"/>
+                        </a:lnSpc>
+                      </a:pPr>
+                      <a:r>
+                        <a:rPr sz="950" b="0">
+                          <a:solidFill>
+                            <a:srgbClr val="1A1A1A"/>
+                          </a:solidFill>
+                        </a:rPr>
+                        <a:t>Con: supplies the destination, not the journey</a:t>
+                      </a:r>
+                    </a:p>
+                  </a:txBody>
+                  <a:tcPr marL="64008" marR="64008" marT="27432" marB="27432">
+                    <a:solidFill>
+                      <a:srgbClr val="CCD7EA"/>
+                    </a:solidFill>
+                  </a:tcPr>
+                </a:tc>
+                <a:tc>
+                  <a:txBody>
+                    <a:bodyPr wrap="square"/>
+                    <a:lstStyle/>
+                    <a:p>
+                      <a:pPr>
+                        <a:lnSpc>
+                          <a:spcPct val="92000"/>
+                        </a:lnSpc>
+                      </a:pPr>
+                      <a:r>
+                        <a:rPr sz="950" b="0">
+                          <a:solidFill>
+                            <a:srgbClr val="1A1A1A"/>
+                          </a:solidFill>
+                        </a:rPr>
+                        <a:t>Primitives are available and interoperable well ahead of adoption</a:t>
+                      </a:r>
+                    </a:p>
+                  </a:txBody>
+                  <a:tcPr marL="64008" marR="64008" marT="27432" marB="27432">
+                    <a:solidFill>
+                      <a:srgbClr val="CCD7EA"/>
+                    </a:solidFill>
+                  </a:tcPr>
+                </a:tc>
+              </a:tr>
+              <a:tr h="792480">
+                <a:tc>
+                  <a:txBody>
+                    <a:bodyPr wrap="square"/>
+                    <a:lstStyle/>
+                    <a:p>
+                      <a:pPr>
+                        <a:lnSpc>
+                          <a:spcPct val="92000"/>
+                        </a:lnSpc>
+                      </a:pPr>
+                      <a:r>
+                        <a:rPr sz="950" b="0">
+                          <a:solidFill>
+                            <a:srgbClr val="1A1A1A"/>
+                          </a:solidFill>
+                        </a:rPr>
+                        <a:t>Chen et al., Evaluating LLMs trained on code (2021)</a:t>
+                      </a:r>
+                    </a:p>
+                  </a:txBody>
+                  <a:tcPr marL="64008" marR="64008" marT="27432" marB="27432">
+                    <a:solidFill>
+                      <a:srgbClr val="DEE6F2"/>
+                    </a:solidFill>
+                  </a:tcPr>
+                </a:tc>
+                <a:tc>
+                  <a:txBody>
+                    <a:bodyPr wrap="square"/>
+                    <a:lstStyle/>
+                    <a:p>
+                      <a:pPr>
+                        <a:lnSpc>
+                          <a:spcPct val="92000"/>
+                        </a:lnSpc>
+                      </a:pPr>
+                      <a:r>
+                        <a:rPr sz="950" b="0">
+                          <a:solidFill>
+                            <a:srgbClr val="1A1A1A"/>
+                          </a:solidFill>
+                        </a:rPr>
+                        <a:t>Assess model-driven source-to-source transformation</a:t>
+                      </a:r>
+                    </a:p>
+                  </a:txBody>
+                  <a:tcPr marL="64008" marR="64008" marT="27432" marB="27432">
+                    <a:solidFill>
+                      <a:srgbClr val="DEE6F2"/>
+                    </a:solidFill>
+                  </a:tcPr>
+                </a:tc>
+                <a:tc>
+                  <a:txBody>
+                    <a:bodyPr wrap="square"/>
+                    <a:lstStyle/>
+                    <a:p>
+                      <a:pPr>
+                        <a:lnSpc>
+                          <a:spcPct val="92000"/>
+                        </a:lnSpc>
+                      </a:pPr>
+                      <a:r>
+                        <a:rPr sz="950" b="0">
+                          <a:solidFill>
+                            <a:srgbClr val="1A1A1A"/>
+                          </a:solidFill>
+                        </a:rPr>
+                        <a:t>Benchmark generated code against functional tests</a:t>
+                      </a:r>
+                    </a:p>
+                  </a:txBody>
+                  <a:tcPr marL="64008" marR="64008" marT="27432" marB="27432">
+                    <a:solidFill>
+                      <a:srgbClr val="DEE6F2"/>
+                    </a:solidFill>
+                  </a:tcPr>
+                </a:tc>
+                <a:tc>
+                  <a:txBody>
+                    <a:bodyPr wrap="square"/>
+                    <a:lstStyle/>
+                    <a:p>
+                      <a:pPr>
+                        <a:lnSpc>
+                          <a:spcPct val="92000"/>
+                        </a:lnSpc>
+                      </a:pPr>
+                      <a:r>
+                        <a:rPr sz="950" b="0">
+                          <a:solidFill>
+                            <a:srgbClr val="1A1A1A"/>
+                          </a:solidFill>
+                        </a:rPr>
+                        <a:t>Pro: handles code shapes rules cannot match.</a:t>
+                      </a:r>
+                    </a:p>
+                    <a:p>
+                      <a:pPr>
+                        <a:lnSpc>
+                          <a:spcPct val="92000"/>
+                        </a:lnSpc>
+                      </a:pPr>
+                      <a:r>
+                        <a:rPr sz="950" b="0">
+                          <a:solidFill>
+                            <a:srgbClr val="1A1A1A"/>
+                          </a:solidFill>
+                        </a:rPr>
+                        <a:t>Con: output requires human verification</a:t>
+                      </a:r>
+                    </a:p>
+                  </a:txBody>
+                  <a:tcPr marL="64008" marR="64008" marT="27432" marB="27432">
+                    <a:solidFill>
+                      <a:srgbClr val="DEE6F2"/>
+                    </a:solidFill>
+                  </a:tcPr>
+                </a:tc>
+                <a:tc>
+                  <a:txBody>
+                    <a:bodyPr wrap="square"/>
+                    <a:lstStyle/>
+                    <a:p>
+                      <a:pPr>
+                        <a:lnSpc>
+                          <a:spcPct val="92000"/>
+                        </a:lnSpc>
+                      </a:pPr>
+                      <a:r>
+                        <a:rPr sz="950" b="0">
+                          <a:solidFill>
+                            <a:srgbClr val="1A1A1A"/>
+                          </a:solidFill>
+                        </a:rPr>
+                        <a:t>A plausible patch is indistinguishable from a correct one without execution</a:t>
+                      </a:r>
+                    </a:p>
+                  </a:txBody>
+                  <a:tcPr marL="64008" marR="64008" marT="27432" marB="27432">
+                    <a:solidFill>
+                      <a:srgbClr val="DEE6F2"/>
+                    </a:solidFill>
+                  </a:tcPr>
+                </a:tc>
+              </a:tr>
+              <a:tr h="792480">
+                <a:tc>
+                  <a:txBody>
+                    <a:bodyPr wrap="square"/>
+                    <a:lstStyle/>
+                    <a:p>
+                      <a:pPr>
+                        <a:lnSpc>
+                          <a:spcPct val="92000"/>
+                        </a:lnSpc>
+                      </a:pPr>
+                      <a:r>
+                        <a:rPr sz="950" b="0">
+                          <a:solidFill>
+                            <a:srgbClr val="1A1A1A"/>
+                          </a:solidFill>
+                        </a:rPr>
+                        <a:t>Mosca (2018); Barker et al., NIST white paper (2021)</a:t>
+                      </a:r>
+                    </a:p>
+                  </a:txBody>
+                  <a:tcPr marL="64008" marR="64008" marT="27432" marB="27432">
+                    <a:solidFill>
+                      <a:srgbClr val="CCD7EA"/>
+                    </a:solidFill>
+                  </a:tcPr>
+                </a:tc>
+                <a:tc>
+                  <a:txBody>
+                    <a:bodyPr wrap="square"/>
+                    <a:lstStyle/>
+                    <a:p>
+                      <a:pPr>
+                        <a:lnSpc>
+                          <a:spcPct val="92000"/>
+                        </a:lnSpc>
+                      </a:pPr>
+                      <a:r>
+                        <a:rPr sz="950" b="0">
+                          <a:solidFill>
+                            <a:srgbClr val="1A1A1A"/>
+                          </a:solidFill>
+                        </a:rPr>
+                        <a:t>Frame the urgency and organisational readiness problem</a:t>
+                      </a:r>
+                    </a:p>
+                  </a:txBody>
+                  <a:tcPr marL="64008" marR="64008" marT="27432" marB="27432">
+                    <a:solidFill>
+                      <a:srgbClr val="CCD7EA"/>
+                    </a:solidFill>
+                  </a:tcPr>
+                </a:tc>
+                <a:tc>
+                  <a:txBody>
+                    <a:bodyPr wrap="square"/>
+                    <a:lstStyle/>
+                    <a:p>
+                      <a:pPr>
+                        <a:lnSpc>
+                          <a:spcPct val="92000"/>
+                        </a:lnSpc>
+                      </a:pPr>
+                      <a:r>
+                        <a:rPr sz="950" b="0">
+                          <a:solidFill>
+                            <a:srgbClr val="1A1A1A"/>
+                          </a:solidFill>
+                        </a:rPr>
+                        <a:t>Risk analysis of the harvest-now-decrypt-later threat</a:t>
+                      </a:r>
+                    </a:p>
+                  </a:txBody>
+                  <a:tcPr marL="64008" marR="64008" marT="27432" marB="27432">
+                    <a:solidFill>
+                      <a:srgbClr val="CCD7EA"/>
+                    </a:solidFill>
+                  </a:tcPr>
+                </a:tc>
+                <a:tc>
+                  <a:txBody>
+                    <a:bodyPr wrap="square"/>
+                    <a:lstStyle/>
+                    <a:p>
+                      <a:pPr>
+                        <a:lnSpc>
+                          <a:spcPct val="92000"/>
+                        </a:lnSpc>
+                      </a:pPr>
+                      <a:r>
+                        <a:rPr sz="950" b="0">
+                          <a:solidFill>
+                            <a:srgbClr val="1A1A1A"/>
+                          </a:solidFill>
+                        </a:rPr>
+                        <a:t>Pro: justifies acting before quantum hardware exists.</a:t>
+                      </a:r>
+                    </a:p>
+                    <a:p>
+                      <a:pPr>
+                        <a:lnSpc>
+                          <a:spcPct val="92000"/>
+                        </a:lnSpc>
+                      </a:pPr>
+                      <a:r>
+                        <a:rPr sz="950" b="0">
+                          <a:solidFill>
+                            <a:srgbClr val="1A1A1A"/>
+                          </a:solidFill>
+                        </a:rPr>
+                        <a:t>Con: no technical migration path</a:t>
+                      </a:r>
+                    </a:p>
+                  </a:txBody>
+                  <a:tcPr marL="64008" marR="64008" marT="27432" marB="27432">
+                    <a:solidFill>
+                      <a:srgbClr val="CCD7EA"/>
+                    </a:solidFill>
+                  </a:tcPr>
+                </a:tc>
+                <a:tc>
+                  <a:txBody>
+                    <a:bodyPr wrap="square"/>
+                    <a:lstStyle/>
+                    <a:p>
+                      <a:pPr>
+                        <a:lnSpc>
+                          <a:spcPct val="92000"/>
+                        </a:lnSpc>
+                      </a:pPr>
+                      <a:r>
+                        <a:rPr sz="950" b="0">
+                          <a:solidFill>
+                            <a:srgbClr val="1A1A1A"/>
+                          </a:solidFill>
+                        </a:rPr>
+                        <a:t>Long-lived data is already exposed; migration cannot wait for the threat</a:t>
+                      </a:r>
+                    </a:p>
+                  </a:txBody>
+                  <a:tcPr marL="64008" marR="64008" marT="27432" marB="27432">
+                    <a:solidFill>
+                      <a:srgbClr val="CCD7EA"/>
+                    </a:solidFill>
+                  </a:tcPr>
+                </a:tc>
+              </a:tr>
+            </a:tbl>
+          </a:graphicData>
+        </a:graphic>
+      </p:graphicFrame>
     </p:spTree>
     <p:extLst>
       <p:ext uri="{BB962C8B-B14F-4D97-AF65-F5344CB8AC3E}">

</xml_diff>

<commit_message>
Add the web app and Vercel deployment
A single-page front end that runs the whole pipeline in the browser: findings
table, recommendations with rationale, a before/after diff of the rewritten
source, verification checks and a live benchmark.

- api/_engine.py holds the pipeline logic, so the code exercised by the local
  dev server is exactly what the serverless function runs
- api/analyze.py is the Vercel Python entry point
- public/ is the static front end, no external dependencies
- dev_server.py serves public/ and the same engine for local work

Pasted code is analysed and rewritten but never executed; only the three
bundled samples are run, so the public endpoint cannot be used to execute
arbitrary code.

Co-Authored-By: Claude Opus 5 <noreply@anthropic.com>
</commit_message>
<xml_diff>
--- a/report/Review_3_Team_20106UG02.pptx
+++ b/report/Review_3_Team_20106UG02.pptx
@@ -122,7 +122,18 @@
   </p:defaultTextStyle>
   <p:extLst>
     <p:ext uri="{EFAFB233-063F-42B5-8137-9DF3F51BA10A}">
-      <p15:sldGuideLst xmlns:p15="http://schemas.microsoft.com/office/powerpoint/2012/main" xmlns=""/>
+      <p15:sldGuideLst xmlns:p15="http://schemas.microsoft.com/office/powerpoint/2012/main">
+        <p15:guide id="1" orient="horz" pos="2160">
+          <p15:clr>
+            <a:srgbClr val="A4A3A4"/>
+          </p15:clr>
+        </p15:guide>
+        <p15:guide id="2" pos="3840">
+          <p15:clr>
+            <a:srgbClr val="A4A3A4"/>
+          </p15:clr>
+        </p15:guide>
+      </p15:sldGuideLst>
     </p:ext>
   </p:extLst>
 </p:presentation>
@@ -210,7 +221,7 @@
           <a:p>
             <a:fld id="{C058E2E1-8886-43B2-B986-F2B06DAA2FAC}" type="datetimeFigureOut">
               <a:rPr lang="en-IN" smtClean="0"/>
-              <a:t>05/10/26</a:t>
+              <a:t>25-10-2026</a:t>
             </a:fld>
             <a:endParaRPr lang="en-IN"/>
           </a:p>
@@ -500,7 +511,7 @@
           <p:cNvPr id="2" name="Title 1">
             <a:extLst>
               <a:ext uri="{FF2B5EF4-FFF2-40B4-BE49-F238E27FC236}">
-                <a16:creationId xmlns:a16="http://schemas.microsoft.com/office/drawing/2014/main" xmlns="" id="{342592BF-19BE-9BF0-E2FC-07A36D054E1D}"/>
+                <a16:creationId xmlns:a16="http://schemas.microsoft.com/office/drawing/2014/main" id="{342592BF-19BE-9BF0-E2FC-07A36D054E1D}"/>
               </a:ext>
             </a:extLst>
           </p:cNvPr>
@@ -538,7 +549,7 @@
           <p:cNvPr id="3" name="Subtitle 2">
             <a:extLst>
               <a:ext uri="{FF2B5EF4-FFF2-40B4-BE49-F238E27FC236}">
-                <a16:creationId xmlns:a16="http://schemas.microsoft.com/office/drawing/2014/main" xmlns="" id="{383AB4F9-CBB3-B18D-E917-C3B06418676D}"/>
+                <a16:creationId xmlns:a16="http://schemas.microsoft.com/office/drawing/2014/main" id="{383AB4F9-CBB3-B18D-E917-C3B06418676D}"/>
               </a:ext>
             </a:extLst>
           </p:cNvPr>
@@ -609,7 +620,7 @@
           <p:cNvPr id="4" name="Date Placeholder 3">
             <a:extLst>
               <a:ext uri="{FF2B5EF4-FFF2-40B4-BE49-F238E27FC236}">
-                <a16:creationId xmlns:a16="http://schemas.microsoft.com/office/drawing/2014/main" xmlns="" id="{F50F18A0-E201-1900-A139-E830DD3EA1D1}"/>
+                <a16:creationId xmlns:a16="http://schemas.microsoft.com/office/drawing/2014/main" id="{F50F18A0-E201-1900-A139-E830DD3EA1D1}"/>
               </a:ext>
             </a:extLst>
           </p:cNvPr>
@@ -627,7 +638,7 @@
           <a:p>
             <a:fld id="{8F3E78AE-7F97-4550-9DD8-BF69171FDC30}" type="datetime1">
               <a:rPr lang="en-IN" smtClean="0"/>
-              <a:t>05/10/26</a:t>
+              <a:t>25-10-2026</a:t>
             </a:fld>
             <a:endParaRPr lang="en-IN"/>
           </a:p>
@@ -638,7 +649,7 @@
           <p:cNvPr id="5" name="Footer Placeholder 4">
             <a:extLst>
               <a:ext uri="{FF2B5EF4-FFF2-40B4-BE49-F238E27FC236}">
-                <a16:creationId xmlns:a16="http://schemas.microsoft.com/office/drawing/2014/main" xmlns="" id="{ED0906B9-B1F6-B52E-2EE0-7595B1EBF0FF}"/>
+                <a16:creationId xmlns:a16="http://schemas.microsoft.com/office/drawing/2014/main" id="{ED0906B9-B1F6-B52E-2EE0-7595B1EBF0FF}"/>
               </a:ext>
             </a:extLst>
           </p:cNvPr>
@@ -666,7 +677,7 @@
           <p:cNvPr id="6" name="Slide Number Placeholder 5">
             <a:extLst>
               <a:ext uri="{FF2B5EF4-FFF2-40B4-BE49-F238E27FC236}">
-                <a16:creationId xmlns:a16="http://schemas.microsoft.com/office/drawing/2014/main" xmlns="" id="{97A13AE1-F96E-D540-8DE1-8D903DB30CE2}"/>
+                <a16:creationId xmlns:a16="http://schemas.microsoft.com/office/drawing/2014/main" id="{97A13AE1-F96E-D540-8DE1-8D903DB30CE2}"/>
               </a:ext>
             </a:extLst>
           </p:cNvPr>
@@ -725,7 +736,7 @@
           <p:cNvPr id="2" name="Title 1">
             <a:extLst>
               <a:ext uri="{FF2B5EF4-FFF2-40B4-BE49-F238E27FC236}">
-                <a16:creationId xmlns:a16="http://schemas.microsoft.com/office/drawing/2014/main" xmlns="" id="{7E71D7EC-16EA-5009-5D33-ABFC55F28132}"/>
+                <a16:creationId xmlns:a16="http://schemas.microsoft.com/office/drawing/2014/main" id="{7E71D7EC-16EA-5009-5D33-ABFC55F28132}"/>
               </a:ext>
             </a:extLst>
           </p:cNvPr>
@@ -754,7 +765,7 @@
           <p:cNvPr id="3" name="Vertical Text Placeholder 2">
             <a:extLst>
               <a:ext uri="{FF2B5EF4-FFF2-40B4-BE49-F238E27FC236}">
-                <a16:creationId xmlns:a16="http://schemas.microsoft.com/office/drawing/2014/main" xmlns="" id="{EB09EC6D-8ED5-29E9-9444-CC2D6A1CB8A3}"/>
+                <a16:creationId xmlns:a16="http://schemas.microsoft.com/office/drawing/2014/main" id="{EB09EC6D-8ED5-29E9-9444-CC2D6A1CB8A3}"/>
               </a:ext>
             </a:extLst>
           </p:cNvPr>
@@ -812,7 +823,7 @@
           <p:cNvPr id="4" name="Date Placeholder 3">
             <a:extLst>
               <a:ext uri="{FF2B5EF4-FFF2-40B4-BE49-F238E27FC236}">
-                <a16:creationId xmlns:a16="http://schemas.microsoft.com/office/drawing/2014/main" xmlns="" id="{3C1ADFC6-7CEA-ABEE-94C2-870B1E65737A}"/>
+                <a16:creationId xmlns:a16="http://schemas.microsoft.com/office/drawing/2014/main" id="{3C1ADFC6-7CEA-ABEE-94C2-870B1E65737A}"/>
               </a:ext>
             </a:extLst>
           </p:cNvPr>
@@ -830,7 +841,7 @@
           <a:p>
             <a:fld id="{5576931C-EA1A-43DD-B3B3-66F5BA587712}" type="datetime1">
               <a:rPr lang="en-IN" smtClean="0"/>
-              <a:t>05/10/26</a:t>
+              <a:t>25-10-2026</a:t>
             </a:fld>
             <a:endParaRPr lang="en-IN"/>
           </a:p>
@@ -841,7 +852,7 @@
           <p:cNvPr id="5" name="Footer Placeholder 4">
             <a:extLst>
               <a:ext uri="{FF2B5EF4-FFF2-40B4-BE49-F238E27FC236}">
-                <a16:creationId xmlns:a16="http://schemas.microsoft.com/office/drawing/2014/main" xmlns="" id="{7B1FA3A5-596E-6C2A-F853-30C5DC6FBF0D}"/>
+                <a16:creationId xmlns:a16="http://schemas.microsoft.com/office/drawing/2014/main" id="{7B1FA3A5-596E-6C2A-F853-30C5DC6FBF0D}"/>
               </a:ext>
             </a:extLst>
           </p:cNvPr>
@@ -869,7 +880,7 @@
           <p:cNvPr id="6" name="Slide Number Placeholder 5">
             <a:extLst>
               <a:ext uri="{FF2B5EF4-FFF2-40B4-BE49-F238E27FC236}">
-                <a16:creationId xmlns:a16="http://schemas.microsoft.com/office/drawing/2014/main" xmlns="" id="{312CE6B1-CE87-B68F-9494-FA6D109F3896}"/>
+                <a16:creationId xmlns:a16="http://schemas.microsoft.com/office/drawing/2014/main" id="{312CE6B1-CE87-B68F-9494-FA6D109F3896}"/>
               </a:ext>
             </a:extLst>
           </p:cNvPr>
@@ -928,7 +939,7 @@
           <p:cNvPr id="2" name="Vertical Title 1">
             <a:extLst>
               <a:ext uri="{FF2B5EF4-FFF2-40B4-BE49-F238E27FC236}">
-                <a16:creationId xmlns:a16="http://schemas.microsoft.com/office/drawing/2014/main" xmlns="" id="{AF0FF105-FC99-2BCB-131F-2B902F8BAE21}"/>
+                <a16:creationId xmlns:a16="http://schemas.microsoft.com/office/drawing/2014/main" id="{AF0FF105-FC99-2BCB-131F-2B902F8BAE21}"/>
               </a:ext>
             </a:extLst>
           </p:cNvPr>
@@ -962,7 +973,7 @@
           <p:cNvPr id="3" name="Vertical Text Placeholder 2">
             <a:extLst>
               <a:ext uri="{FF2B5EF4-FFF2-40B4-BE49-F238E27FC236}">
-                <a16:creationId xmlns:a16="http://schemas.microsoft.com/office/drawing/2014/main" xmlns="" id="{50354FD6-064F-6E12-E8DE-81EC913CDB0B}"/>
+                <a16:creationId xmlns:a16="http://schemas.microsoft.com/office/drawing/2014/main" id="{50354FD6-064F-6E12-E8DE-81EC913CDB0B}"/>
               </a:ext>
             </a:extLst>
           </p:cNvPr>
@@ -1025,7 +1036,7 @@
           <p:cNvPr id="4" name="Date Placeholder 3">
             <a:extLst>
               <a:ext uri="{FF2B5EF4-FFF2-40B4-BE49-F238E27FC236}">
-                <a16:creationId xmlns:a16="http://schemas.microsoft.com/office/drawing/2014/main" xmlns="" id="{EF1D2109-32D1-4A0F-F903-5142A204EF48}"/>
+                <a16:creationId xmlns:a16="http://schemas.microsoft.com/office/drawing/2014/main" id="{EF1D2109-32D1-4A0F-F903-5142A204EF48}"/>
               </a:ext>
             </a:extLst>
           </p:cNvPr>
@@ -1043,7 +1054,7 @@
           <a:p>
             <a:fld id="{82C9B0E1-7C95-4C20-B9C6-BA51F388E878}" type="datetime1">
               <a:rPr lang="en-IN" smtClean="0"/>
-              <a:t>05/10/26</a:t>
+              <a:t>25-10-2026</a:t>
             </a:fld>
             <a:endParaRPr lang="en-IN"/>
           </a:p>
@@ -1054,7 +1065,7 @@
           <p:cNvPr id="5" name="Footer Placeholder 4">
             <a:extLst>
               <a:ext uri="{FF2B5EF4-FFF2-40B4-BE49-F238E27FC236}">
-                <a16:creationId xmlns:a16="http://schemas.microsoft.com/office/drawing/2014/main" xmlns="" id="{73E5353D-EEF9-CF3C-A97F-F0F0EBFA7C59}"/>
+                <a16:creationId xmlns:a16="http://schemas.microsoft.com/office/drawing/2014/main" id="{73E5353D-EEF9-CF3C-A97F-F0F0EBFA7C59}"/>
               </a:ext>
             </a:extLst>
           </p:cNvPr>
@@ -1082,7 +1093,7 @@
           <p:cNvPr id="6" name="Slide Number Placeholder 5">
             <a:extLst>
               <a:ext uri="{FF2B5EF4-FFF2-40B4-BE49-F238E27FC236}">
-                <a16:creationId xmlns:a16="http://schemas.microsoft.com/office/drawing/2014/main" xmlns="" id="{3DF2F1DC-3958-BCDE-9A16-88E928E7ED2D}"/>
+                <a16:creationId xmlns:a16="http://schemas.microsoft.com/office/drawing/2014/main" id="{3DF2F1DC-3958-BCDE-9A16-88E928E7ED2D}"/>
               </a:ext>
             </a:extLst>
           </p:cNvPr>
@@ -1141,7 +1152,7 @@
           <p:cNvPr id="2" name="Title 1">
             <a:extLst>
               <a:ext uri="{FF2B5EF4-FFF2-40B4-BE49-F238E27FC236}">
-                <a16:creationId xmlns:a16="http://schemas.microsoft.com/office/drawing/2014/main" xmlns="" id="{7532F7EA-3EC9-99AF-13A9-22A3F8B2D21C}"/>
+                <a16:creationId xmlns:a16="http://schemas.microsoft.com/office/drawing/2014/main" id="{7532F7EA-3EC9-99AF-13A9-22A3F8B2D21C}"/>
               </a:ext>
             </a:extLst>
           </p:cNvPr>
@@ -1170,7 +1181,7 @@
           <p:cNvPr id="3" name="Content Placeholder 2">
             <a:extLst>
               <a:ext uri="{FF2B5EF4-FFF2-40B4-BE49-F238E27FC236}">
-                <a16:creationId xmlns:a16="http://schemas.microsoft.com/office/drawing/2014/main" xmlns="" id="{FC71419B-73DB-15DA-D2EE-0FC01B435F2F}"/>
+                <a16:creationId xmlns:a16="http://schemas.microsoft.com/office/drawing/2014/main" id="{FC71419B-73DB-15DA-D2EE-0FC01B435F2F}"/>
               </a:ext>
             </a:extLst>
           </p:cNvPr>
@@ -1228,7 +1239,7 @@
           <p:cNvPr id="4" name="Date Placeholder 3">
             <a:extLst>
               <a:ext uri="{FF2B5EF4-FFF2-40B4-BE49-F238E27FC236}">
-                <a16:creationId xmlns:a16="http://schemas.microsoft.com/office/drawing/2014/main" xmlns="" id="{AB080259-8D20-E29B-4DC5-312C3DB01BB3}"/>
+                <a16:creationId xmlns:a16="http://schemas.microsoft.com/office/drawing/2014/main" id="{AB080259-8D20-E29B-4DC5-312C3DB01BB3}"/>
               </a:ext>
             </a:extLst>
           </p:cNvPr>
@@ -1246,7 +1257,7 @@
           <a:p>
             <a:fld id="{FEA886FF-1BA7-4533-94E6-869CE1E2970B}" type="datetime1">
               <a:rPr lang="en-IN" smtClean="0"/>
-              <a:t>05/10/26</a:t>
+              <a:t>25-10-2026</a:t>
             </a:fld>
             <a:endParaRPr lang="en-IN"/>
           </a:p>
@@ -1257,7 +1268,7 @@
           <p:cNvPr id="5" name="Footer Placeholder 4">
             <a:extLst>
               <a:ext uri="{FF2B5EF4-FFF2-40B4-BE49-F238E27FC236}">
-                <a16:creationId xmlns:a16="http://schemas.microsoft.com/office/drawing/2014/main" xmlns="" id="{E101830E-3502-194A-88FA-DC3E0F1B309A}"/>
+                <a16:creationId xmlns:a16="http://schemas.microsoft.com/office/drawing/2014/main" id="{E101830E-3502-194A-88FA-DC3E0F1B309A}"/>
               </a:ext>
             </a:extLst>
           </p:cNvPr>
@@ -1285,7 +1296,7 @@
           <p:cNvPr id="6" name="Slide Number Placeholder 5">
             <a:extLst>
               <a:ext uri="{FF2B5EF4-FFF2-40B4-BE49-F238E27FC236}">
-                <a16:creationId xmlns:a16="http://schemas.microsoft.com/office/drawing/2014/main" xmlns="" id="{ECF6703C-229C-43C6-0484-38EC263AD4A9}"/>
+                <a16:creationId xmlns:a16="http://schemas.microsoft.com/office/drawing/2014/main" id="{ECF6703C-229C-43C6-0484-38EC263AD4A9}"/>
               </a:ext>
             </a:extLst>
           </p:cNvPr>
@@ -1344,7 +1355,7 @@
           <p:cNvPr id="2" name="Title 1">
             <a:extLst>
               <a:ext uri="{FF2B5EF4-FFF2-40B4-BE49-F238E27FC236}">
-                <a16:creationId xmlns:a16="http://schemas.microsoft.com/office/drawing/2014/main" xmlns="" id="{7E0CE344-6494-09A6-A5E4-811EEE0CD2A0}"/>
+                <a16:creationId xmlns:a16="http://schemas.microsoft.com/office/drawing/2014/main" id="{7E0CE344-6494-09A6-A5E4-811EEE0CD2A0}"/>
               </a:ext>
             </a:extLst>
           </p:cNvPr>
@@ -1382,7 +1393,7 @@
           <p:cNvPr id="3" name="Text Placeholder 2">
             <a:extLst>
               <a:ext uri="{FF2B5EF4-FFF2-40B4-BE49-F238E27FC236}">
-                <a16:creationId xmlns:a16="http://schemas.microsoft.com/office/drawing/2014/main" xmlns="" id="{7351A0E2-2B9B-B96E-A3FD-0B26BDDBEB4D}"/>
+                <a16:creationId xmlns:a16="http://schemas.microsoft.com/office/drawing/2014/main" id="{7351A0E2-2B9B-B96E-A3FD-0B26BDDBEB4D}"/>
               </a:ext>
             </a:extLst>
           </p:cNvPr>
@@ -1507,7 +1518,7 @@
           <p:cNvPr id="4" name="Date Placeholder 3">
             <a:extLst>
               <a:ext uri="{FF2B5EF4-FFF2-40B4-BE49-F238E27FC236}">
-                <a16:creationId xmlns:a16="http://schemas.microsoft.com/office/drawing/2014/main" xmlns="" id="{A767CE67-8E8A-4D0D-42DF-DDC842B1B17A}"/>
+                <a16:creationId xmlns:a16="http://schemas.microsoft.com/office/drawing/2014/main" id="{A767CE67-8E8A-4D0D-42DF-DDC842B1B17A}"/>
               </a:ext>
             </a:extLst>
           </p:cNvPr>
@@ -1525,7 +1536,7 @@
           <a:p>
             <a:fld id="{93E22BD8-A2C4-424B-809A-C64DDCC305D9}" type="datetime1">
               <a:rPr lang="en-IN" smtClean="0"/>
-              <a:t>05/10/26</a:t>
+              <a:t>25-10-2026</a:t>
             </a:fld>
             <a:endParaRPr lang="en-IN"/>
           </a:p>
@@ -1536,7 +1547,7 @@
           <p:cNvPr id="5" name="Footer Placeholder 4">
             <a:extLst>
               <a:ext uri="{FF2B5EF4-FFF2-40B4-BE49-F238E27FC236}">
-                <a16:creationId xmlns:a16="http://schemas.microsoft.com/office/drawing/2014/main" xmlns="" id="{73A78C3E-C139-1FD1-979B-D71679959D2B}"/>
+                <a16:creationId xmlns:a16="http://schemas.microsoft.com/office/drawing/2014/main" id="{73A78C3E-C139-1FD1-979B-D71679959D2B}"/>
               </a:ext>
             </a:extLst>
           </p:cNvPr>
@@ -1564,7 +1575,7 @@
           <p:cNvPr id="6" name="Slide Number Placeholder 5">
             <a:extLst>
               <a:ext uri="{FF2B5EF4-FFF2-40B4-BE49-F238E27FC236}">
-                <a16:creationId xmlns:a16="http://schemas.microsoft.com/office/drawing/2014/main" xmlns="" id="{9932F297-889B-B694-6DD5-92F8A6AAFF71}"/>
+                <a16:creationId xmlns:a16="http://schemas.microsoft.com/office/drawing/2014/main" id="{9932F297-889B-B694-6DD5-92F8A6AAFF71}"/>
               </a:ext>
             </a:extLst>
           </p:cNvPr>
@@ -1623,7 +1634,7 @@
           <p:cNvPr id="2" name="Title 1">
             <a:extLst>
               <a:ext uri="{FF2B5EF4-FFF2-40B4-BE49-F238E27FC236}">
-                <a16:creationId xmlns:a16="http://schemas.microsoft.com/office/drawing/2014/main" xmlns="" id="{0792C89C-FEA2-11F6-7988-ADD14A7B22F9}"/>
+                <a16:creationId xmlns:a16="http://schemas.microsoft.com/office/drawing/2014/main" id="{0792C89C-FEA2-11F6-7988-ADD14A7B22F9}"/>
               </a:ext>
             </a:extLst>
           </p:cNvPr>
@@ -1652,7 +1663,7 @@
           <p:cNvPr id="3" name="Content Placeholder 2">
             <a:extLst>
               <a:ext uri="{FF2B5EF4-FFF2-40B4-BE49-F238E27FC236}">
-                <a16:creationId xmlns:a16="http://schemas.microsoft.com/office/drawing/2014/main" xmlns="" id="{60E5DE7B-A406-1142-36EA-1C1498740235}"/>
+                <a16:creationId xmlns:a16="http://schemas.microsoft.com/office/drawing/2014/main" id="{60E5DE7B-A406-1142-36EA-1C1498740235}"/>
               </a:ext>
             </a:extLst>
           </p:cNvPr>
@@ -1715,7 +1726,7 @@
           <p:cNvPr id="4" name="Content Placeholder 3">
             <a:extLst>
               <a:ext uri="{FF2B5EF4-FFF2-40B4-BE49-F238E27FC236}">
-                <a16:creationId xmlns:a16="http://schemas.microsoft.com/office/drawing/2014/main" xmlns="" id="{D4355A2B-361E-86CB-ABBE-C510D2B2215F}"/>
+                <a16:creationId xmlns:a16="http://schemas.microsoft.com/office/drawing/2014/main" id="{D4355A2B-361E-86CB-ABBE-C510D2B2215F}"/>
               </a:ext>
             </a:extLst>
           </p:cNvPr>
@@ -1778,7 +1789,7 @@
           <p:cNvPr id="5" name="Date Placeholder 4">
             <a:extLst>
               <a:ext uri="{FF2B5EF4-FFF2-40B4-BE49-F238E27FC236}">
-                <a16:creationId xmlns:a16="http://schemas.microsoft.com/office/drawing/2014/main" xmlns="" id="{50DA5E84-A1E0-A1C4-F7E6-DA9E7B124C77}"/>
+                <a16:creationId xmlns:a16="http://schemas.microsoft.com/office/drawing/2014/main" id="{50DA5E84-A1E0-A1C4-F7E6-DA9E7B124C77}"/>
               </a:ext>
             </a:extLst>
           </p:cNvPr>
@@ -1796,7 +1807,7 @@
           <a:p>
             <a:fld id="{B620F4BC-B3A4-46AF-9AEC-8478EF1369D5}" type="datetime1">
               <a:rPr lang="en-IN" smtClean="0"/>
-              <a:t>05/10/26</a:t>
+              <a:t>25-10-2026</a:t>
             </a:fld>
             <a:endParaRPr lang="en-IN"/>
           </a:p>
@@ -1807,7 +1818,7 @@
           <p:cNvPr id="6" name="Footer Placeholder 5">
             <a:extLst>
               <a:ext uri="{FF2B5EF4-FFF2-40B4-BE49-F238E27FC236}">
-                <a16:creationId xmlns:a16="http://schemas.microsoft.com/office/drawing/2014/main" xmlns="" id="{D5DDA460-54C8-F2AC-C053-53FF3FAFCCD5}"/>
+                <a16:creationId xmlns:a16="http://schemas.microsoft.com/office/drawing/2014/main" id="{D5DDA460-54C8-F2AC-C053-53FF3FAFCCD5}"/>
               </a:ext>
             </a:extLst>
           </p:cNvPr>
@@ -1835,7 +1846,7 @@
           <p:cNvPr id="7" name="Slide Number Placeholder 6">
             <a:extLst>
               <a:ext uri="{FF2B5EF4-FFF2-40B4-BE49-F238E27FC236}">
-                <a16:creationId xmlns:a16="http://schemas.microsoft.com/office/drawing/2014/main" xmlns="" id="{EE6F132A-BD40-58D2-CEEC-A1BA2B9E2EF2}"/>
+                <a16:creationId xmlns:a16="http://schemas.microsoft.com/office/drawing/2014/main" id="{EE6F132A-BD40-58D2-CEEC-A1BA2B9E2EF2}"/>
               </a:ext>
             </a:extLst>
           </p:cNvPr>
@@ -1894,7 +1905,7 @@
           <p:cNvPr id="2" name="Title 1">
             <a:extLst>
               <a:ext uri="{FF2B5EF4-FFF2-40B4-BE49-F238E27FC236}">
-                <a16:creationId xmlns:a16="http://schemas.microsoft.com/office/drawing/2014/main" xmlns="" id="{F05823BE-2514-8722-ED45-41E13E46B674}"/>
+                <a16:creationId xmlns:a16="http://schemas.microsoft.com/office/drawing/2014/main" id="{F05823BE-2514-8722-ED45-41E13E46B674}"/>
               </a:ext>
             </a:extLst>
           </p:cNvPr>
@@ -1928,7 +1939,7 @@
           <p:cNvPr id="3" name="Text Placeholder 2">
             <a:extLst>
               <a:ext uri="{FF2B5EF4-FFF2-40B4-BE49-F238E27FC236}">
-                <a16:creationId xmlns:a16="http://schemas.microsoft.com/office/drawing/2014/main" xmlns="" id="{64BFEE3B-6ABA-1D24-97FE-717EBBC999EA}"/>
+                <a16:creationId xmlns:a16="http://schemas.microsoft.com/office/drawing/2014/main" id="{64BFEE3B-6ABA-1D24-97FE-717EBBC999EA}"/>
               </a:ext>
             </a:extLst>
           </p:cNvPr>
@@ -1999,7 +2010,7 @@
           <p:cNvPr id="4" name="Content Placeholder 3">
             <a:extLst>
               <a:ext uri="{FF2B5EF4-FFF2-40B4-BE49-F238E27FC236}">
-                <a16:creationId xmlns:a16="http://schemas.microsoft.com/office/drawing/2014/main" xmlns="" id="{5C653C42-4C6D-988F-42A0-8639A508A612}"/>
+                <a16:creationId xmlns:a16="http://schemas.microsoft.com/office/drawing/2014/main" id="{5C653C42-4C6D-988F-42A0-8639A508A612}"/>
               </a:ext>
             </a:extLst>
           </p:cNvPr>
@@ -2062,7 +2073,7 @@
           <p:cNvPr id="5" name="Text Placeholder 4">
             <a:extLst>
               <a:ext uri="{FF2B5EF4-FFF2-40B4-BE49-F238E27FC236}">
-                <a16:creationId xmlns:a16="http://schemas.microsoft.com/office/drawing/2014/main" xmlns="" id="{F2B662B4-F942-A78F-394F-74F6037179B2}"/>
+                <a16:creationId xmlns:a16="http://schemas.microsoft.com/office/drawing/2014/main" id="{F2B662B4-F942-A78F-394F-74F6037179B2}"/>
               </a:ext>
             </a:extLst>
           </p:cNvPr>
@@ -2133,7 +2144,7 @@
           <p:cNvPr id="6" name="Content Placeholder 5">
             <a:extLst>
               <a:ext uri="{FF2B5EF4-FFF2-40B4-BE49-F238E27FC236}">
-                <a16:creationId xmlns:a16="http://schemas.microsoft.com/office/drawing/2014/main" xmlns="" id="{5B445FBE-A81E-92E1-36E3-99D1586F8316}"/>
+                <a16:creationId xmlns:a16="http://schemas.microsoft.com/office/drawing/2014/main" id="{5B445FBE-A81E-92E1-36E3-99D1586F8316}"/>
               </a:ext>
             </a:extLst>
           </p:cNvPr>
@@ -2196,7 +2207,7 @@
           <p:cNvPr id="7" name="Date Placeholder 6">
             <a:extLst>
               <a:ext uri="{FF2B5EF4-FFF2-40B4-BE49-F238E27FC236}">
-                <a16:creationId xmlns:a16="http://schemas.microsoft.com/office/drawing/2014/main" xmlns="" id="{B6D20C02-77C2-CB2A-62F8-60B8C62629ED}"/>
+                <a16:creationId xmlns:a16="http://schemas.microsoft.com/office/drawing/2014/main" id="{B6D20C02-77C2-CB2A-62F8-60B8C62629ED}"/>
               </a:ext>
             </a:extLst>
           </p:cNvPr>
@@ -2214,7 +2225,7 @@
           <a:p>
             <a:fld id="{4C9A2993-B405-4F4D-B968-A01C27211659}" type="datetime1">
               <a:rPr lang="en-IN" smtClean="0"/>
-              <a:t>05/10/26</a:t>
+              <a:t>25-10-2026</a:t>
             </a:fld>
             <a:endParaRPr lang="en-IN"/>
           </a:p>
@@ -2225,7 +2236,7 @@
           <p:cNvPr id="8" name="Footer Placeholder 7">
             <a:extLst>
               <a:ext uri="{FF2B5EF4-FFF2-40B4-BE49-F238E27FC236}">
-                <a16:creationId xmlns:a16="http://schemas.microsoft.com/office/drawing/2014/main" xmlns="" id="{AD033241-EB08-777E-F678-5D641F6495A5}"/>
+                <a16:creationId xmlns:a16="http://schemas.microsoft.com/office/drawing/2014/main" id="{AD033241-EB08-777E-F678-5D641F6495A5}"/>
               </a:ext>
             </a:extLst>
           </p:cNvPr>
@@ -2253,7 +2264,7 @@
           <p:cNvPr id="9" name="Slide Number Placeholder 8">
             <a:extLst>
               <a:ext uri="{FF2B5EF4-FFF2-40B4-BE49-F238E27FC236}">
-                <a16:creationId xmlns:a16="http://schemas.microsoft.com/office/drawing/2014/main" xmlns="" id="{40D711ED-181F-C690-A3B3-1D82670FC5D5}"/>
+                <a16:creationId xmlns:a16="http://schemas.microsoft.com/office/drawing/2014/main" id="{40D711ED-181F-C690-A3B3-1D82670FC5D5}"/>
               </a:ext>
             </a:extLst>
           </p:cNvPr>
@@ -2312,7 +2323,7 @@
           <p:cNvPr id="2" name="Title 1">
             <a:extLst>
               <a:ext uri="{FF2B5EF4-FFF2-40B4-BE49-F238E27FC236}">
-                <a16:creationId xmlns:a16="http://schemas.microsoft.com/office/drawing/2014/main" xmlns="" id="{F77468B4-E355-69B3-7598-80ADF2F9CC18}"/>
+                <a16:creationId xmlns:a16="http://schemas.microsoft.com/office/drawing/2014/main" id="{F77468B4-E355-69B3-7598-80ADF2F9CC18}"/>
               </a:ext>
             </a:extLst>
           </p:cNvPr>
@@ -2341,7 +2352,7 @@
           <p:cNvPr id="3" name="Date Placeholder 2">
             <a:extLst>
               <a:ext uri="{FF2B5EF4-FFF2-40B4-BE49-F238E27FC236}">
-                <a16:creationId xmlns:a16="http://schemas.microsoft.com/office/drawing/2014/main" xmlns="" id="{E2F1AB3B-AFC6-3627-62E6-22313061FA80}"/>
+                <a16:creationId xmlns:a16="http://schemas.microsoft.com/office/drawing/2014/main" id="{E2F1AB3B-AFC6-3627-62E6-22313061FA80}"/>
               </a:ext>
             </a:extLst>
           </p:cNvPr>
@@ -2359,7 +2370,7 @@
           <a:p>
             <a:fld id="{79378C8C-5FBB-4DD7-A06D-BE263480794B}" type="datetime1">
               <a:rPr lang="en-IN" smtClean="0"/>
-              <a:t>05/10/26</a:t>
+              <a:t>25-10-2026</a:t>
             </a:fld>
             <a:endParaRPr lang="en-IN"/>
           </a:p>
@@ -2370,7 +2381,7 @@
           <p:cNvPr id="4" name="Footer Placeholder 3">
             <a:extLst>
               <a:ext uri="{FF2B5EF4-FFF2-40B4-BE49-F238E27FC236}">
-                <a16:creationId xmlns:a16="http://schemas.microsoft.com/office/drawing/2014/main" xmlns="" id="{2B2C6591-48E4-480E-7965-DE9F830154A3}"/>
+                <a16:creationId xmlns:a16="http://schemas.microsoft.com/office/drawing/2014/main" id="{2B2C6591-48E4-480E-7965-DE9F830154A3}"/>
               </a:ext>
             </a:extLst>
           </p:cNvPr>
@@ -2398,7 +2409,7 @@
           <p:cNvPr id="5" name="Slide Number Placeholder 4">
             <a:extLst>
               <a:ext uri="{FF2B5EF4-FFF2-40B4-BE49-F238E27FC236}">
-                <a16:creationId xmlns:a16="http://schemas.microsoft.com/office/drawing/2014/main" xmlns="" id="{F10C9D68-A16A-B2D3-C8A6-B5221AF744BC}"/>
+                <a16:creationId xmlns:a16="http://schemas.microsoft.com/office/drawing/2014/main" id="{F10C9D68-A16A-B2D3-C8A6-B5221AF744BC}"/>
               </a:ext>
             </a:extLst>
           </p:cNvPr>
@@ -2457,7 +2468,7 @@
           <p:cNvPr id="2" name="Date Placeholder 1">
             <a:extLst>
               <a:ext uri="{FF2B5EF4-FFF2-40B4-BE49-F238E27FC236}">
-                <a16:creationId xmlns:a16="http://schemas.microsoft.com/office/drawing/2014/main" xmlns="" id="{A23F289A-3AD7-C11D-1594-90A35E592B5C}"/>
+                <a16:creationId xmlns:a16="http://schemas.microsoft.com/office/drawing/2014/main" id="{A23F289A-3AD7-C11D-1594-90A35E592B5C}"/>
               </a:ext>
             </a:extLst>
           </p:cNvPr>
@@ -2475,7 +2486,7 @@
           <a:p>
             <a:fld id="{31FD2985-06EC-459B-80C8-F6F4362A1C03}" type="datetime1">
               <a:rPr lang="en-IN" smtClean="0"/>
-              <a:t>05/10/26</a:t>
+              <a:t>25-10-2026</a:t>
             </a:fld>
             <a:endParaRPr lang="en-IN"/>
           </a:p>
@@ -2486,7 +2497,7 @@
           <p:cNvPr id="3" name="Footer Placeholder 2">
             <a:extLst>
               <a:ext uri="{FF2B5EF4-FFF2-40B4-BE49-F238E27FC236}">
-                <a16:creationId xmlns:a16="http://schemas.microsoft.com/office/drawing/2014/main" xmlns="" id="{8C252269-BBE3-199F-299B-38D4E9CC1899}"/>
+                <a16:creationId xmlns:a16="http://schemas.microsoft.com/office/drawing/2014/main" id="{8C252269-BBE3-199F-299B-38D4E9CC1899}"/>
               </a:ext>
             </a:extLst>
           </p:cNvPr>
@@ -2514,7 +2525,7 @@
           <p:cNvPr id="4" name="Slide Number Placeholder 3">
             <a:extLst>
               <a:ext uri="{FF2B5EF4-FFF2-40B4-BE49-F238E27FC236}">
-                <a16:creationId xmlns:a16="http://schemas.microsoft.com/office/drawing/2014/main" xmlns="" id="{F7407FDC-B2A9-1304-047F-5808A0B6B226}"/>
+                <a16:creationId xmlns:a16="http://schemas.microsoft.com/office/drawing/2014/main" id="{F7407FDC-B2A9-1304-047F-5808A0B6B226}"/>
               </a:ext>
             </a:extLst>
           </p:cNvPr>
@@ -2573,7 +2584,7 @@
           <p:cNvPr id="2" name="Title 1">
             <a:extLst>
               <a:ext uri="{FF2B5EF4-FFF2-40B4-BE49-F238E27FC236}">
-                <a16:creationId xmlns:a16="http://schemas.microsoft.com/office/drawing/2014/main" xmlns="" id="{F25A4847-FC20-D9BF-0BDE-26EC7EF7435D}"/>
+                <a16:creationId xmlns:a16="http://schemas.microsoft.com/office/drawing/2014/main" id="{F25A4847-FC20-D9BF-0BDE-26EC7EF7435D}"/>
               </a:ext>
             </a:extLst>
           </p:cNvPr>
@@ -2611,7 +2622,7 @@
           <p:cNvPr id="3" name="Content Placeholder 2">
             <a:extLst>
               <a:ext uri="{FF2B5EF4-FFF2-40B4-BE49-F238E27FC236}">
-                <a16:creationId xmlns:a16="http://schemas.microsoft.com/office/drawing/2014/main" xmlns="" id="{68D9C584-AC19-D7B4-9DFE-7C1BC2E1BCC5}"/>
+                <a16:creationId xmlns:a16="http://schemas.microsoft.com/office/drawing/2014/main" id="{68D9C584-AC19-D7B4-9DFE-7C1BC2E1BCC5}"/>
               </a:ext>
             </a:extLst>
           </p:cNvPr>
@@ -2702,7 +2713,7 @@
           <p:cNvPr id="4" name="Text Placeholder 3">
             <a:extLst>
               <a:ext uri="{FF2B5EF4-FFF2-40B4-BE49-F238E27FC236}">
-                <a16:creationId xmlns:a16="http://schemas.microsoft.com/office/drawing/2014/main" xmlns="" id="{2F4A3262-CE8D-2419-DCCC-C536E9FDAC37}"/>
+                <a16:creationId xmlns:a16="http://schemas.microsoft.com/office/drawing/2014/main" id="{2F4A3262-CE8D-2419-DCCC-C536E9FDAC37}"/>
               </a:ext>
             </a:extLst>
           </p:cNvPr>
@@ -2773,7 +2784,7 @@
           <p:cNvPr id="5" name="Date Placeholder 4">
             <a:extLst>
               <a:ext uri="{FF2B5EF4-FFF2-40B4-BE49-F238E27FC236}">
-                <a16:creationId xmlns:a16="http://schemas.microsoft.com/office/drawing/2014/main" xmlns="" id="{294758D6-7AF2-29C5-E0EE-3B7BE155EC20}"/>
+                <a16:creationId xmlns:a16="http://schemas.microsoft.com/office/drawing/2014/main" id="{294758D6-7AF2-29C5-E0EE-3B7BE155EC20}"/>
               </a:ext>
             </a:extLst>
           </p:cNvPr>
@@ -2791,7 +2802,7 @@
           <a:p>
             <a:fld id="{71D7E9DA-13C6-48A4-9305-B592482DE8CE}" type="datetime1">
               <a:rPr lang="en-IN" smtClean="0"/>
-              <a:t>05/10/26</a:t>
+              <a:t>25-10-2026</a:t>
             </a:fld>
             <a:endParaRPr lang="en-IN"/>
           </a:p>
@@ -2802,7 +2813,7 @@
           <p:cNvPr id="6" name="Footer Placeholder 5">
             <a:extLst>
               <a:ext uri="{FF2B5EF4-FFF2-40B4-BE49-F238E27FC236}">
-                <a16:creationId xmlns:a16="http://schemas.microsoft.com/office/drawing/2014/main" xmlns="" id="{45AAC7E7-68C4-7616-2DE1-0333E2C446CC}"/>
+                <a16:creationId xmlns:a16="http://schemas.microsoft.com/office/drawing/2014/main" id="{45AAC7E7-68C4-7616-2DE1-0333E2C446CC}"/>
               </a:ext>
             </a:extLst>
           </p:cNvPr>
@@ -2830,7 +2841,7 @@
           <p:cNvPr id="7" name="Slide Number Placeholder 6">
             <a:extLst>
               <a:ext uri="{FF2B5EF4-FFF2-40B4-BE49-F238E27FC236}">
-                <a16:creationId xmlns:a16="http://schemas.microsoft.com/office/drawing/2014/main" xmlns="" id="{5E9EF51B-1685-66FF-0783-23584C251751}"/>
+                <a16:creationId xmlns:a16="http://schemas.microsoft.com/office/drawing/2014/main" id="{5E9EF51B-1685-66FF-0783-23584C251751}"/>
               </a:ext>
             </a:extLst>
           </p:cNvPr>
@@ -2889,7 +2900,7 @@
           <p:cNvPr id="2" name="Title 1">
             <a:extLst>
               <a:ext uri="{FF2B5EF4-FFF2-40B4-BE49-F238E27FC236}">
-                <a16:creationId xmlns:a16="http://schemas.microsoft.com/office/drawing/2014/main" xmlns="" id="{13939D0E-3A71-7252-C837-B8281F0DED9C}"/>
+                <a16:creationId xmlns:a16="http://schemas.microsoft.com/office/drawing/2014/main" id="{13939D0E-3A71-7252-C837-B8281F0DED9C}"/>
               </a:ext>
             </a:extLst>
           </p:cNvPr>
@@ -2927,7 +2938,7 @@
           <p:cNvPr id="3" name="Picture Placeholder 2">
             <a:extLst>
               <a:ext uri="{FF2B5EF4-FFF2-40B4-BE49-F238E27FC236}">
-                <a16:creationId xmlns:a16="http://schemas.microsoft.com/office/drawing/2014/main" xmlns="" id="{AFE3D557-6893-299F-57A8-A7B173F10143}"/>
+                <a16:creationId xmlns:a16="http://schemas.microsoft.com/office/drawing/2014/main" id="{AFE3D557-6893-299F-57A8-A7B173F10143}"/>
               </a:ext>
             </a:extLst>
           </p:cNvPr>
@@ -2994,7 +3005,7 @@
           <p:cNvPr id="4" name="Text Placeholder 3">
             <a:extLst>
               <a:ext uri="{FF2B5EF4-FFF2-40B4-BE49-F238E27FC236}">
-                <a16:creationId xmlns:a16="http://schemas.microsoft.com/office/drawing/2014/main" xmlns="" id="{C4CC8BA2-BB08-F4E3-5660-C7370BA568C3}"/>
+                <a16:creationId xmlns:a16="http://schemas.microsoft.com/office/drawing/2014/main" id="{C4CC8BA2-BB08-F4E3-5660-C7370BA568C3}"/>
               </a:ext>
             </a:extLst>
           </p:cNvPr>
@@ -3065,7 +3076,7 @@
           <p:cNvPr id="5" name="Date Placeholder 4">
             <a:extLst>
               <a:ext uri="{FF2B5EF4-FFF2-40B4-BE49-F238E27FC236}">
-                <a16:creationId xmlns:a16="http://schemas.microsoft.com/office/drawing/2014/main" xmlns="" id="{CE57E1CE-C7CA-966D-8661-1E99A7DA2174}"/>
+                <a16:creationId xmlns:a16="http://schemas.microsoft.com/office/drawing/2014/main" id="{CE57E1CE-C7CA-966D-8661-1E99A7DA2174}"/>
               </a:ext>
             </a:extLst>
           </p:cNvPr>
@@ -3083,7 +3094,7 @@
           <a:p>
             <a:fld id="{F45E7C4B-C575-4DCF-9B63-045662930500}" type="datetime1">
               <a:rPr lang="en-IN" smtClean="0"/>
-              <a:t>05/10/26</a:t>
+              <a:t>25-10-2026</a:t>
             </a:fld>
             <a:endParaRPr lang="en-IN"/>
           </a:p>
@@ -3094,7 +3105,7 @@
           <p:cNvPr id="6" name="Footer Placeholder 5">
             <a:extLst>
               <a:ext uri="{FF2B5EF4-FFF2-40B4-BE49-F238E27FC236}">
-                <a16:creationId xmlns:a16="http://schemas.microsoft.com/office/drawing/2014/main" xmlns="" id="{66055516-3E64-07E5-10C5-DE056657E44B}"/>
+                <a16:creationId xmlns:a16="http://schemas.microsoft.com/office/drawing/2014/main" id="{66055516-3E64-07E5-10C5-DE056657E44B}"/>
               </a:ext>
             </a:extLst>
           </p:cNvPr>
@@ -3122,7 +3133,7 @@
           <p:cNvPr id="7" name="Slide Number Placeholder 6">
             <a:extLst>
               <a:ext uri="{FF2B5EF4-FFF2-40B4-BE49-F238E27FC236}">
-                <a16:creationId xmlns:a16="http://schemas.microsoft.com/office/drawing/2014/main" xmlns="" id="{AFBA5AD5-9867-E76D-C035-2856CCFBC128}"/>
+                <a16:creationId xmlns:a16="http://schemas.microsoft.com/office/drawing/2014/main" id="{AFBA5AD5-9867-E76D-C035-2856CCFBC128}"/>
               </a:ext>
             </a:extLst>
           </p:cNvPr>
@@ -3186,7 +3197,7 @@
           <p:cNvPr id="2" name="Title Placeholder 1">
             <a:extLst>
               <a:ext uri="{FF2B5EF4-FFF2-40B4-BE49-F238E27FC236}">
-                <a16:creationId xmlns:a16="http://schemas.microsoft.com/office/drawing/2014/main" xmlns="" id="{85454249-E28B-CF91-F4A6-9762E4F38B7D}"/>
+                <a16:creationId xmlns:a16="http://schemas.microsoft.com/office/drawing/2014/main" id="{85454249-E28B-CF91-F4A6-9762E4F38B7D}"/>
               </a:ext>
             </a:extLst>
           </p:cNvPr>
@@ -3225,7 +3236,7 @@
           <p:cNvPr id="3" name="Text Placeholder 2">
             <a:extLst>
               <a:ext uri="{FF2B5EF4-FFF2-40B4-BE49-F238E27FC236}">
-                <a16:creationId xmlns:a16="http://schemas.microsoft.com/office/drawing/2014/main" xmlns="" id="{21E3D641-7C66-CA7D-30A7-7F95AC27EF4C}"/>
+                <a16:creationId xmlns:a16="http://schemas.microsoft.com/office/drawing/2014/main" id="{21E3D641-7C66-CA7D-30A7-7F95AC27EF4C}"/>
               </a:ext>
             </a:extLst>
           </p:cNvPr>
@@ -3293,7 +3304,7 @@
           <p:cNvPr id="4" name="Date Placeholder 3">
             <a:extLst>
               <a:ext uri="{FF2B5EF4-FFF2-40B4-BE49-F238E27FC236}">
-                <a16:creationId xmlns:a16="http://schemas.microsoft.com/office/drawing/2014/main" xmlns="" id="{B5E1D408-B228-838E-3E43-4304680A536B}"/>
+                <a16:creationId xmlns:a16="http://schemas.microsoft.com/office/drawing/2014/main" id="{B5E1D408-B228-838E-3E43-4304680A536B}"/>
               </a:ext>
             </a:extLst>
           </p:cNvPr>
@@ -3329,7 +3340,7 @@
           <a:p>
             <a:fld id="{43827C3E-786B-4150-9177-1C28966A2ADC}" type="datetime1">
               <a:rPr lang="en-IN" smtClean="0"/>
-              <a:t>05/10/26</a:t>
+              <a:t>25-10-2026</a:t>
             </a:fld>
             <a:endParaRPr lang="en-IN"/>
           </a:p>
@@ -3340,7 +3351,7 @@
           <p:cNvPr id="5" name="Footer Placeholder 4">
             <a:extLst>
               <a:ext uri="{FF2B5EF4-FFF2-40B4-BE49-F238E27FC236}">
-                <a16:creationId xmlns:a16="http://schemas.microsoft.com/office/drawing/2014/main" xmlns="" id="{DCEC7A69-1922-F157-900C-FF956683161C}"/>
+                <a16:creationId xmlns:a16="http://schemas.microsoft.com/office/drawing/2014/main" id="{DCEC7A69-1922-F157-900C-FF956683161C}"/>
               </a:ext>
             </a:extLst>
           </p:cNvPr>
@@ -3386,7 +3397,7 @@
           <p:cNvPr id="6" name="Slide Number Placeholder 5">
             <a:extLst>
               <a:ext uri="{FF2B5EF4-FFF2-40B4-BE49-F238E27FC236}">
-                <a16:creationId xmlns:a16="http://schemas.microsoft.com/office/drawing/2014/main" xmlns="" id="{51B80E76-E345-1553-9664-0BCF569B55B9}"/>
+                <a16:creationId xmlns:a16="http://schemas.microsoft.com/office/drawing/2014/main" id="{51B80E76-E345-1553-9664-0BCF569B55B9}"/>
               </a:ext>
             </a:extLst>
           </p:cNvPr>
@@ -3755,7 +3766,7 @@
           <p:cNvPr id="5" name="Picture 4">
             <a:extLst>
               <a:ext uri="{FF2B5EF4-FFF2-40B4-BE49-F238E27FC236}">
-                <a16:creationId xmlns:a16="http://schemas.microsoft.com/office/drawing/2014/main" xmlns="" id="{3E9E27CD-EF84-CB3A-3D07-A3152356892A}"/>
+                <a16:creationId xmlns:a16="http://schemas.microsoft.com/office/drawing/2014/main" id="{3E9E27CD-EF84-CB3A-3D07-A3152356892A}"/>
               </a:ext>
             </a:extLst>
           </p:cNvPr>
@@ -3785,7 +3796,7 @@
           <p:cNvPr id="7" name="Title 6">
             <a:extLst>
               <a:ext uri="{FF2B5EF4-FFF2-40B4-BE49-F238E27FC236}">
-                <a16:creationId xmlns:a16="http://schemas.microsoft.com/office/drawing/2014/main" xmlns="" id="{8BAD67C4-20B4-E1F6-A7E7-C8C33181D0C9}"/>
+                <a16:creationId xmlns:a16="http://schemas.microsoft.com/office/drawing/2014/main" id="{8BAD67C4-20B4-E1F6-A7E7-C8C33181D0C9}"/>
               </a:ext>
             </a:extLst>
           </p:cNvPr>
@@ -3831,7 +3842,7 @@
           <p:cNvPr id="9" name="object 3">
             <a:extLst>
               <a:ext uri="{FF2B5EF4-FFF2-40B4-BE49-F238E27FC236}">
-                <a16:creationId xmlns:a16="http://schemas.microsoft.com/office/drawing/2014/main" xmlns="" id="{68BC382C-506F-4908-6AC3-C0AA73064F47}"/>
+                <a16:creationId xmlns:a16="http://schemas.microsoft.com/office/drawing/2014/main" id="{68BC382C-506F-4908-6AC3-C0AA73064F47}"/>
               </a:ext>
             </a:extLst>
           </p:cNvPr>
@@ -3940,6 +3951,11 @@
                 <a:spcPts val="600"/>
               </a:spcAft>
             </a:pPr>
+            <a:endParaRPr sz="1500" b="0">
+              <a:solidFill>
+                <a:srgbClr val="1A1A1A"/>
+              </a:solidFill>
+            </a:endParaRPr>
           </a:p>
           <a:p>
             <a:pPr>
@@ -3986,6 +4002,11 @@
                 <a:spcPts val="600"/>
               </a:spcAft>
             </a:pPr>
+            <a:endParaRPr sz="1500" b="0">
+              <a:solidFill>
+                <a:srgbClr val="1A1A1A"/>
+              </a:solidFill>
+            </a:endParaRPr>
           </a:p>
           <a:p>
             <a:pPr>
@@ -4017,13 +4038,6 @@
   <p:clrMapOvr>
     <a:masterClrMapping/>
   </p:clrMapOvr>
-  <p:timing>
-    <p:tnLst>
-      <p:par>
-        <p:cTn xmlns:p14="http://schemas.microsoft.com/office/powerpoint/2010/main" id="1" dur="indefinite" restart="never" nodeType="tmRoot"/>
-      </p:par>
-    </p:tnLst>
-  </p:timing>
 </p:sld>
 </file>
 
@@ -4035,7 +4049,7 @@
         <p:cNvPr id="1" name="">
           <a:extLst>
             <a:ext uri="{FF2B5EF4-FFF2-40B4-BE49-F238E27FC236}">
-              <a16:creationId xmlns:a16="http://schemas.microsoft.com/office/drawing/2014/main" xmlns="" id="{4D42F2ED-50F9-3DFA-95BB-1A1059C5D893}"/>
+              <a16:creationId xmlns:a16="http://schemas.microsoft.com/office/drawing/2014/main" id="{4D42F2ED-50F9-3DFA-95BB-1A1059C5D893}"/>
             </a:ext>
           </a:extLst>
         </p:cNvPr>
@@ -4055,7 +4069,7 @@
           <p:cNvPr id="3" name="Content Placeholder 2">
             <a:extLst>
               <a:ext uri="{FF2B5EF4-FFF2-40B4-BE49-F238E27FC236}">
-                <a16:creationId xmlns:a16="http://schemas.microsoft.com/office/drawing/2014/main" xmlns="" id="{A93F2560-A5FE-A724-8F39-E7E901E8FADC}"/>
+                <a16:creationId xmlns:a16="http://schemas.microsoft.com/office/drawing/2014/main" id="{A93F2560-A5FE-A724-8F39-E7E901E8FADC}"/>
               </a:ext>
             </a:extLst>
           </p:cNvPr>
@@ -4205,7 +4219,7 @@
           <p:cNvPr id="4" name="object 2">
             <a:extLst>
               <a:ext uri="{FF2B5EF4-FFF2-40B4-BE49-F238E27FC236}">
-                <a16:creationId xmlns:a16="http://schemas.microsoft.com/office/drawing/2014/main" xmlns="" id="{B27DA514-48FC-4BF4-8205-DE21D456C5FF}"/>
+                <a16:creationId xmlns:a16="http://schemas.microsoft.com/office/drawing/2014/main" id="{B27DA514-48FC-4BF4-8205-DE21D456C5FF}"/>
               </a:ext>
             </a:extLst>
           </p:cNvPr>
@@ -4258,7 +4272,7 @@
           <p:cNvPr id="2" name="Date Placeholder 1">
             <a:extLst>
               <a:ext uri="{FF2B5EF4-FFF2-40B4-BE49-F238E27FC236}">
-                <a16:creationId xmlns:a16="http://schemas.microsoft.com/office/drawing/2014/main" xmlns="" id="{D74A04E0-6631-130F-A154-C85D978EA39B}"/>
+                <a16:creationId xmlns:a16="http://schemas.microsoft.com/office/drawing/2014/main" id="{D74A04E0-6631-130F-A154-C85D978EA39B}"/>
               </a:ext>
             </a:extLst>
           </p:cNvPr>
@@ -4279,7 +4293,7 @@
                 <a:latin typeface="Times New Roman" panose="02020603050405020304" pitchFamily="18" charset="0"/>
                 <a:cs typeface="Times New Roman" panose="02020603050405020304" pitchFamily="18" charset="0"/>
               </a:rPr>
-              <a:t>05/10/26</a:t>
+              <a:t>25-10-2026</a:t>
             </a:fld>
             <a:endParaRPr lang="en-IN">
               <a:latin typeface="Times New Roman" panose="02020603050405020304" pitchFamily="18" charset="0"/>
@@ -4293,7 +4307,7 @@
           <p:cNvPr id="5" name="Footer Placeholder 4">
             <a:extLst>
               <a:ext uri="{FF2B5EF4-FFF2-40B4-BE49-F238E27FC236}">
-                <a16:creationId xmlns:a16="http://schemas.microsoft.com/office/drawing/2014/main" xmlns="" id="{39615995-EDEB-C984-B852-1229C23B1A05}"/>
+                <a16:creationId xmlns:a16="http://schemas.microsoft.com/office/drawing/2014/main" id="{39615995-EDEB-C984-B852-1229C23B1A05}"/>
               </a:ext>
             </a:extLst>
           </p:cNvPr>
@@ -4324,7 +4338,7 @@
           <p:cNvPr id="6" name="Slide Number Placeholder 5">
             <a:extLst>
               <a:ext uri="{FF2B5EF4-FFF2-40B4-BE49-F238E27FC236}">
-                <a16:creationId xmlns:a16="http://schemas.microsoft.com/office/drawing/2014/main" xmlns="" id="{067F5109-389C-3E37-E553-A559233EFD96}"/>
+                <a16:creationId xmlns:a16="http://schemas.microsoft.com/office/drawing/2014/main" id="{067F5109-389C-3E37-E553-A559233EFD96}"/>
               </a:ext>
             </a:extLst>
           </p:cNvPr>
@@ -4375,7 +4389,7 @@
         <p:cNvPr id="1" name="">
           <a:extLst>
             <a:ext uri="{FF2B5EF4-FFF2-40B4-BE49-F238E27FC236}">
-              <a16:creationId xmlns:a16="http://schemas.microsoft.com/office/drawing/2014/main" xmlns="" id="{121556E8-0003-02C5-D37D-A5CC4CE44D5B}"/>
+              <a16:creationId xmlns:a16="http://schemas.microsoft.com/office/drawing/2014/main" id="{121556E8-0003-02C5-D37D-A5CC4CE44D5B}"/>
             </a:ext>
           </a:extLst>
         </p:cNvPr>
@@ -4395,7 +4409,7 @@
           <p:cNvPr id="3" name="Content Placeholder 2">
             <a:extLst>
               <a:ext uri="{FF2B5EF4-FFF2-40B4-BE49-F238E27FC236}">
-                <a16:creationId xmlns:a16="http://schemas.microsoft.com/office/drawing/2014/main" xmlns="" id="{DFB67973-736B-B05D-D378-DA7CBE3EBDAD}"/>
+                <a16:creationId xmlns:a16="http://schemas.microsoft.com/office/drawing/2014/main" id="{DFB67973-736B-B05D-D378-DA7CBE3EBDAD}"/>
               </a:ext>
             </a:extLst>
           </p:cNvPr>
@@ -4496,7 +4510,7 @@
           <p:cNvPr id="4" name="object 2">
             <a:extLst>
               <a:ext uri="{FF2B5EF4-FFF2-40B4-BE49-F238E27FC236}">
-                <a16:creationId xmlns:a16="http://schemas.microsoft.com/office/drawing/2014/main" xmlns="" id="{E386D544-A80A-B599-44C7-B40BA6ECC63C}"/>
+                <a16:creationId xmlns:a16="http://schemas.microsoft.com/office/drawing/2014/main" id="{E386D544-A80A-B599-44C7-B40BA6ECC63C}"/>
               </a:ext>
             </a:extLst>
           </p:cNvPr>
@@ -4549,7 +4563,7 @@
           <p:cNvPr id="2" name="Date Placeholder 1">
             <a:extLst>
               <a:ext uri="{FF2B5EF4-FFF2-40B4-BE49-F238E27FC236}">
-                <a16:creationId xmlns:a16="http://schemas.microsoft.com/office/drawing/2014/main" xmlns="" id="{5D376B32-FA12-4961-0DBF-EE57A7705BF9}"/>
+                <a16:creationId xmlns:a16="http://schemas.microsoft.com/office/drawing/2014/main" id="{5D376B32-FA12-4961-0DBF-EE57A7705BF9}"/>
               </a:ext>
             </a:extLst>
           </p:cNvPr>
@@ -4570,7 +4584,7 @@
                 <a:latin typeface="Times New Roman" panose="02020603050405020304" pitchFamily="18" charset="0"/>
                 <a:cs typeface="Times New Roman" panose="02020603050405020304" pitchFamily="18" charset="0"/>
               </a:rPr>
-              <a:t>05/10/26</a:t>
+              <a:t>25-10-2026</a:t>
             </a:fld>
             <a:endParaRPr lang="en-IN">
               <a:latin typeface="Times New Roman" panose="02020603050405020304" pitchFamily="18" charset="0"/>
@@ -4584,7 +4598,7 @@
           <p:cNvPr id="5" name="Footer Placeholder 4">
             <a:extLst>
               <a:ext uri="{FF2B5EF4-FFF2-40B4-BE49-F238E27FC236}">
-                <a16:creationId xmlns:a16="http://schemas.microsoft.com/office/drawing/2014/main" xmlns="" id="{8B0EF323-27AB-5372-4287-A24CA541146A}"/>
+                <a16:creationId xmlns:a16="http://schemas.microsoft.com/office/drawing/2014/main" id="{8B0EF323-27AB-5372-4287-A24CA541146A}"/>
               </a:ext>
             </a:extLst>
           </p:cNvPr>
@@ -4615,7 +4629,7 @@
           <p:cNvPr id="6" name="Slide Number Placeholder 5">
             <a:extLst>
               <a:ext uri="{FF2B5EF4-FFF2-40B4-BE49-F238E27FC236}">
-                <a16:creationId xmlns:a16="http://schemas.microsoft.com/office/drawing/2014/main" xmlns="" id="{76AAAC16-1233-230F-5D3B-645E6B2832A4}"/>
+                <a16:creationId xmlns:a16="http://schemas.microsoft.com/office/drawing/2014/main" id="{76AAAC16-1233-230F-5D3B-645E6B2832A4}"/>
               </a:ext>
             </a:extLst>
           </p:cNvPr>
@@ -4690,7 +4704,7 @@
         <p:cNvPr id="1" name="">
           <a:extLst>
             <a:ext uri="{FF2B5EF4-FFF2-40B4-BE49-F238E27FC236}">
-              <a16:creationId xmlns:a16="http://schemas.microsoft.com/office/drawing/2014/main" xmlns="" id="{BCC49A39-F362-DB35-B5DF-7E322AB9CAE0}"/>
+              <a16:creationId xmlns:a16="http://schemas.microsoft.com/office/drawing/2014/main" id="{BCC49A39-F362-DB35-B5DF-7E322AB9CAE0}"/>
             </a:ext>
           </a:extLst>
         </p:cNvPr>
@@ -4710,7 +4724,7 @@
           <p:cNvPr id="3" name="Content Placeholder 2">
             <a:extLst>
               <a:ext uri="{FF2B5EF4-FFF2-40B4-BE49-F238E27FC236}">
-                <a16:creationId xmlns:a16="http://schemas.microsoft.com/office/drawing/2014/main" xmlns="" id="{004F33DD-84F0-A7F9-A1DC-A4DEA1A7D846}"/>
+                <a16:creationId xmlns:a16="http://schemas.microsoft.com/office/drawing/2014/main" id="{004F33DD-84F0-A7F9-A1DC-A4DEA1A7D846}"/>
               </a:ext>
             </a:extLst>
           </p:cNvPr>
@@ -4860,7 +4874,7 @@
           <p:cNvPr id="4" name="object 2">
             <a:extLst>
               <a:ext uri="{FF2B5EF4-FFF2-40B4-BE49-F238E27FC236}">
-                <a16:creationId xmlns:a16="http://schemas.microsoft.com/office/drawing/2014/main" xmlns="" id="{3754A46F-4AC3-5AF1-0B78-C0B5112BD14C}"/>
+                <a16:creationId xmlns:a16="http://schemas.microsoft.com/office/drawing/2014/main" id="{3754A46F-4AC3-5AF1-0B78-C0B5112BD14C}"/>
               </a:ext>
             </a:extLst>
           </p:cNvPr>
@@ -4913,7 +4927,7 @@
           <p:cNvPr id="2" name="Date Placeholder 1">
             <a:extLst>
               <a:ext uri="{FF2B5EF4-FFF2-40B4-BE49-F238E27FC236}">
-                <a16:creationId xmlns:a16="http://schemas.microsoft.com/office/drawing/2014/main" xmlns="" id="{851BAA61-633E-E24B-7DEE-4B2A2B1FA9A4}"/>
+                <a16:creationId xmlns:a16="http://schemas.microsoft.com/office/drawing/2014/main" id="{851BAA61-633E-E24B-7DEE-4B2A2B1FA9A4}"/>
               </a:ext>
             </a:extLst>
           </p:cNvPr>
@@ -4934,7 +4948,7 @@
                 <a:latin typeface="Times New Roman" panose="02020603050405020304" pitchFamily="18" charset="0"/>
                 <a:cs typeface="Times New Roman" panose="02020603050405020304" pitchFamily="18" charset="0"/>
               </a:rPr>
-              <a:t>05/10/26</a:t>
+              <a:t>25-10-2026</a:t>
             </a:fld>
             <a:endParaRPr lang="en-IN">
               <a:latin typeface="Times New Roman" panose="02020603050405020304" pitchFamily="18" charset="0"/>
@@ -4948,7 +4962,7 @@
           <p:cNvPr id="5" name="Footer Placeholder 4">
             <a:extLst>
               <a:ext uri="{FF2B5EF4-FFF2-40B4-BE49-F238E27FC236}">
-                <a16:creationId xmlns:a16="http://schemas.microsoft.com/office/drawing/2014/main" xmlns="" id="{AB93C553-2D0C-5A0A-39DC-21C43BD88BF0}"/>
+                <a16:creationId xmlns:a16="http://schemas.microsoft.com/office/drawing/2014/main" id="{AB93C553-2D0C-5A0A-39DC-21C43BD88BF0}"/>
               </a:ext>
             </a:extLst>
           </p:cNvPr>
@@ -4979,7 +4993,7 @@
           <p:cNvPr id="6" name="Slide Number Placeholder 5">
             <a:extLst>
               <a:ext uri="{FF2B5EF4-FFF2-40B4-BE49-F238E27FC236}">
-                <a16:creationId xmlns:a16="http://schemas.microsoft.com/office/drawing/2014/main" xmlns="" id="{6BF7A7E9-45BE-62F4-D3A6-F19DC6ABEDE6}"/>
+                <a16:creationId xmlns:a16="http://schemas.microsoft.com/office/drawing/2014/main" id="{6BF7A7E9-45BE-62F4-D3A6-F19DC6ABEDE6}"/>
               </a:ext>
             </a:extLst>
           </p:cNvPr>
@@ -5044,7 +5058,7 @@
           <p:cNvPr id="2" name="Title 1">
             <a:extLst>
               <a:ext uri="{FF2B5EF4-FFF2-40B4-BE49-F238E27FC236}">
-                <a16:creationId xmlns:a16="http://schemas.microsoft.com/office/drawing/2014/main" xmlns="" id="{751EE89F-6F96-DF9C-768A-8B2A7BEAD23D}"/>
+                <a16:creationId xmlns:a16="http://schemas.microsoft.com/office/drawing/2014/main" id="{751EE89F-6F96-DF9C-768A-8B2A7BEAD23D}"/>
               </a:ext>
             </a:extLst>
           </p:cNvPr>
@@ -5075,7 +5089,7 @@
           <p:cNvPr id="3" name="Content Placeholder 2">
             <a:extLst>
               <a:ext uri="{FF2B5EF4-FFF2-40B4-BE49-F238E27FC236}">
-                <a16:creationId xmlns:a16="http://schemas.microsoft.com/office/drawing/2014/main" xmlns="" id="{B65DBCB3-75D0-D33A-66EA-4DDA4A02213E}"/>
+                <a16:creationId xmlns:a16="http://schemas.microsoft.com/office/drawing/2014/main" id="{B65DBCB3-75D0-D33A-66EA-4DDA4A02213E}"/>
               </a:ext>
             </a:extLst>
           </p:cNvPr>
@@ -5089,7 +5103,7 @@
         <p:spPr/>
         <p:txBody>
           <a:bodyPr wrap="square">
-            <a:normAutofit fontScale="92500" lnSpcReduction="20000"/>
+            <a:normAutofit/>
           </a:bodyPr>
           <a:lstStyle/>
           <a:p>
@@ -5102,7 +5116,7 @@
               </a:spcAft>
             </a:pPr>
             <a:r>
-              <a:rPr sz="1400" b="1">
+              <a:rPr sz="1400" b="1" dirty="0">
                 <a:solidFill>
                   <a:srgbClr val="1A1A1A"/>
                 </a:solidFill>
@@ -5120,12 +5134,28 @@
               </a:spcAft>
             </a:pPr>
             <a:r>
-              <a:rPr sz="1400" b="0">
+              <a:rPr sz="1400" b="0" dirty="0">
                 <a:solidFill>
                   <a:srgbClr val="1A1A1A"/>
                 </a:solidFill>
               </a:rPr>
-              <a:t>Status: full paper drafted — 8 sections, 5 result tables, measured evaluation. Target venue to be finalised with the guide.</a:t>
+              <a:t>Status: full paper drafted — 8 sections, 5 result tables, measured evaluation. Target venue to be </a:t>
+            </a:r>
+            <a:r>
+              <a:rPr sz="1400" b="0" dirty="0" err="1">
+                <a:solidFill>
+                  <a:srgbClr val="1A1A1A"/>
+                </a:solidFill>
+              </a:rPr>
+              <a:t>finalised</a:t>
+            </a:r>
+            <a:r>
+              <a:rPr sz="1400" b="0" dirty="0">
+                <a:solidFill>
+                  <a:srgbClr val="1A1A1A"/>
+                </a:solidFill>
+              </a:rPr>
+              <a:t> with the guide.</a:t>
             </a:r>
           </a:p>
           <a:p>
@@ -5138,7 +5168,7 @@
               </a:spcAft>
             </a:pPr>
             <a:r>
-              <a:rPr sz="1400" b="0">
+              <a:rPr sz="1400" b="0" dirty="0">
                 <a:solidFill>
                   <a:srgbClr val="1A1A1A"/>
                 </a:solidFill>
@@ -5146,24 +5176,6 @@
               <a:t>Title: “From Detection to Verified Replacement: An End-to-End Framework for Post-Quantum Cryptographic Migration of Python Codebases”</a:t>
             </a:r>
           </a:p>
-          <a:p>
-            <a:pPr>
-              <a:lnSpc>
-                <a:spcPct val="100000"/>
-              </a:lnSpc>
-              <a:spcAft>
-                <a:spcPts val="600"/>
-              </a:spcAft>
-            </a:pPr>
-            <a:r>
-              <a:rPr sz="1400" b="0" i="1">
-                <a:solidFill>
-                  <a:srgbClr val="A03020"/>
-                </a:solidFill>
-              </a:rPr>
-              <a:t>[Replace this slide with the submission / acceptance screenshot once the paper is submitted, and upload the proof to the given link before 27 Oct 2026.]</a:t>
-            </a:r>
-          </a:p>
         </p:txBody>
       </p:sp>
       <p:sp>
@@ -5171,7 +5183,7 @@
           <p:cNvPr id="4" name="Date Placeholder 3">
             <a:extLst>
               <a:ext uri="{FF2B5EF4-FFF2-40B4-BE49-F238E27FC236}">
-                <a16:creationId xmlns:a16="http://schemas.microsoft.com/office/drawing/2014/main" xmlns="" id="{7F86E621-0A63-DDD2-60A0-511D9D7C817E}"/>
+                <a16:creationId xmlns:a16="http://schemas.microsoft.com/office/drawing/2014/main" id="{7F86E621-0A63-DDD2-60A0-511D9D7C817E}"/>
               </a:ext>
             </a:extLst>
           </p:cNvPr>
@@ -5189,7 +5201,7 @@
           <a:p>
             <a:fld id="{FEA886FF-1BA7-4533-94E6-869CE1E2970B}" type="datetime1">
               <a:rPr lang="en-IN" smtClean="0"/>
-              <a:t>05/10/26</a:t>
+              <a:t>25-10-2026</a:t>
             </a:fld>
             <a:endParaRPr lang="en-IN"/>
           </a:p>
@@ -5200,7 +5212,7 @@
           <p:cNvPr id="5" name="Footer Placeholder 4">
             <a:extLst>
               <a:ext uri="{FF2B5EF4-FFF2-40B4-BE49-F238E27FC236}">
-                <a16:creationId xmlns:a16="http://schemas.microsoft.com/office/drawing/2014/main" xmlns="" id="{74966F66-9685-CC43-3B74-035A03CAF328}"/>
+                <a16:creationId xmlns:a16="http://schemas.microsoft.com/office/drawing/2014/main" id="{74966F66-9685-CC43-3B74-035A03CAF328}"/>
               </a:ext>
             </a:extLst>
           </p:cNvPr>
@@ -5228,7 +5240,7 @@
           <p:cNvPr id="6" name="Slide Number Placeholder 5">
             <a:extLst>
               <a:ext uri="{FF2B5EF4-FFF2-40B4-BE49-F238E27FC236}">
-                <a16:creationId xmlns:a16="http://schemas.microsoft.com/office/drawing/2014/main" xmlns="" id="{32234F7B-54B7-5C34-9356-A94BE39E2151}"/>
+                <a16:creationId xmlns:a16="http://schemas.microsoft.com/office/drawing/2014/main" id="{32234F7B-54B7-5C34-9356-A94BE39E2151}"/>
               </a:ext>
             </a:extLst>
           </p:cNvPr>
@@ -5273,7 +5285,7 @@
         <p:cNvPr id="1" name="">
           <a:extLst>
             <a:ext uri="{FF2B5EF4-FFF2-40B4-BE49-F238E27FC236}">
-              <a16:creationId xmlns:a16="http://schemas.microsoft.com/office/drawing/2014/main" xmlns="" id="{2F70E1A0-FA4A-8258-6E10-9F00EDC0BC8B}"/>
+              <a16:creationId xmlns:a16="http://schemas.microsoft.com/office/drawing/2014/main" id="{2F70E1A0-FA4A-8258-6E10-9F00EDC0BC8B}"/>
             </a:ext>
           </a:extLst>
         </p:cNvPr>
@@ -5293,7 +5305,7 @@
           <p:cNvPr id="4" name="object 2">
             <a:extLst>
               <a:ext uri="{FF2B5EF4-FFF2-40B4-BE49-F238E27FC236}">
-                <a16:creationId xmlns:a16="http://schemas.microsoft.com/office/drawing/2014/main" xmlns="" id="{7CFC0C65-61CC-E657-43F7-99C8E5362448}"/>
+                <a16:creationId xmlns:a16="http://schemas.microsoft.com/office/drawing/2014/main" id="{7CFC0C65-61CC-E657-43F7-99C8E5362448}"/>
               </a:ext>
             </a:extLst>
           </p:cNvPr>
@@ -5346,7 +5358,7 @@
           <p:cNvPr id="2" name="Rectangle 3">
             <a:extLst>
               <a:ext uri="{FF2B5EF4-FFF2-40B4-BE49-F238E27FC236}">
-                <a16:creationId xmlns:a16="http://schemas.microsoft.com/office/drawing/2014/main" xmlns="" id="{CC4F09CD-956A-B8B3-1183-9C28C80DDB9A}"/>
+                <a16:creationId xmlns:a16="http://schemas.microsoft.com/office/drawing/2014/main" id="{CC4F09CD-956A-B8B3-1183-9C28C80DDB9A}"/>
               </a:ext>
             </a:extLst>
           </p:cNvPr>
@@ -5372,14 +5384,14 @@
           <a:effectLst/>
           <a:extLst>
             <a:ext uri="{909E8E84-426E-40dd-AFC4-6F175D3DCCD1}">
-              <a14:hiddenFill xmlns:a14="http://schemas.microsoft.com/office/drawing/2010/main">
+              <a14:hiddenFill xmlns:a14="http://schemas.microsoft.com/office/drawing/2010/main" xmlns="">
                 <a:solidFill>
                   <a:schemeClr val="accent1"/>
                 </a:solidFill>
               </a14:hiddenFill>
             </a:ext>
             <a:ext uri="{91240B29-F687-4f45-9708-019B960494DF}">
-              <a14:hiddenLine xmlns:a14="http://schemas.microsoft.com/office/drawing/2010/main" w="9525">
+              <a14:hiddenLine xmlns:a14="http://schemas.microsoft.com/office/drawing/2010/main" xmlns="" w="9525">
                 <a:solidFill>
                   <a:schemeClr val="tx1"/>
                 </a:solidFill>
@@ -5389,7 +5401,7 @@
               </a14:hiddenLine>
             </a:ext>
             <a:ext uri="{AF507438-7753-43e0-B8FC-AC1667EBCBE1}">
-              <a14:hiddenEffects xmlns:a14="http://schemas.microsoft.com/office/drawing/2010/main">
+              <a14:hiddenEffects xmlns:a14="http://schemas.microsoft.com/office/drawing/2010/main" xmlns="">
                 <a:effectLst>
                   <a:outerShdw dist="35921" dir="2700000" algn="ctr" rotWithShape="0">
                     <a:schemeClr val="bg2"/>
@@ -5799,7 +5811,7 @@
           <p:cNvPr id="5" name="Date Placeholder 4">
             <a:extLst>
               <a:ext uri="{FF2B5EF4-FFF2-40B4-BE49-F238E27FC236}">
-                <a16:creationId xmlns:a16="http://schemas.microsoft.com/office/drawing/2014/main" xmlns="" id="{B732D3DB-7149-E1E5-D5F9-4FC93A788894}"/>
+                <a16:creationId xmlns:a16="http://schemas.microsoft.com/office/drawing/2014/main" id="{B732D3DB-7149-E1E5-D5F9-4FC93A788894}"/>
               </a:ext>
             </a:extLst>
           </p:cNvPr>
@@ -5817,7 +5829,7 @@
           <a:p>
             <a:fld id="{0A7C7B6C-E68D-4047-8A1E-3C7BD2842AF7}" type="datetime1">
               <a:rPr lang="en-IN" smtClean="0"/>
-              <a:t>05/10/26</a:t>
+              <a:t>25-10-2026</a:t>
             </a:fld>
             <a:endParaRPr lang="en-IN"/>
           </a:p>
@@ -5828,7 +5840,7 @@
           <p:cNvPr id="6" name="Footer Placeholder 5">
             <a:extLst>
               <a:ext uri="{FF2B5EF4-FFF2-40B4-BE49-F238E27FC236}">
-                <a16:creationId xmlns:a16="http://schemas.microsoft.com/office/drawing/2014/main" xmlns="" id="{CEBCABB1-7C63-52E3-2815-3651AE7E9F7B}"/>
+                <a16:creationId xmlns:a16="http://schemas.microsoft.com/office/drawing/2014/main" id="{CEBCABB1-7C63-52E3-2815-3651AE7E9F7B}"/>
               </a:ext>
             </a:extLst>
           </p:cNvPr>
@@ -5856,7 +5868,7 @@
           <p:cNvPr id="7" name="Slide Number Placeholder 6">
             <a:extLst>
               <a:ext uri="{FF2B5EF4-FFF2-40B4-BE49-F238E27FC236}">
-                <a16:creationId xmlns:a16="http://schemas.microsoft.com/office/drawing/2014/main" xmlns="" id="{E431EAEC-BCE3-2979-69C6-273309B9FFA7}"/>
+                <a16:creationId xmlns:a16="http://schemas.microsoft.com/office/drawing/2014/main" id="{E431EAEC-BCE3-2979-69C6-273309B9FFA7}"/>
               </a:ext>
             </a:extLst>
           </p:cNvPr>
@@ -5915,7 +5927,7 @@
           <p:cNvPr id="2" name="Title 1">
             <a:extLst>
               <a:ext uri="{FF2B5EF4-FFF2-40B4-BE49-F238E27FC236}">
-                <a16:creationId xmlns:a16="http://schemas.microsoft.com/office/drawing/2014/main" xmlns="" id="{A6ACBE13-A9D6-9564-DA47-597E38E09F70}"/>
+                <a16:creationId xmlns:a16="http://schemas.microsoft.com/office/drawing/2014/main" id="{A6ACBE13-A9D6-9564-DA47-597E38E09F70}"/>
               </a:ext>
             </a:extLst>
           </p:cNvPr>
@@ -5948,7 +5960,7 @@
           <p:cNvPr id="3" name="Content Placeholder 2">
             <a:extLst>
               <a:ext uri="{FF2B5EF4-FFF2-40B4-BE49-F238E27FC236}">
-                <a16:creationId xmlns:a16="http://schemas.microsoft.com/office/drawing/2014/main" xmlns="" id="{8233367C-DAD6-6E34-D21A-A981C09442F2}"/>
+                <a16:creationId xmlns:a16="http://schemas.microsoft.com/office/drawing/2014/main" id="{8233367C-DAD6-6E34-D21A-A981C09442F2}"/>
               </a:ext>
             </a:extLst>
           </p:cNvPr>
@@ -5972,15 +5984,7 @@
                   <a:srgbClr val="FFFF00"/>
                 </a:highlight>
               </a:rPr>
-              <a:t>Get the approval for the following points from your guide through mail before  21-10-2026.(sample attached below</a:t>
-            </a:r>
-            <a:r>
-              <a:rPr lang="en-IN" i="1" dirty="0" smtClean="0">
-                <a:highlight>
-                  <a:srgbClr val="FFFF00"/>
-                </a:highlight>
-              </a:rPr>
-              <a:t>)</a:t>
+              <a:t>Get the approval for the following points from your guide through mail before  21-10-2026.(sample attached below)</a:t>
             </a:r>
           </a:p>
           <a:p>
@@ -5991,20 +5995,6 @@
             </a:endParaRPr>
           </a:p>
           <a:p>
-            <a:endParaRPr lang="en-IN" i="1" dirty="0" smtClean="0">
-              <a:highlight>
-                <a:srgbClr val="FFFF00"/>
-              </a:highlight>
-            </a:endParaRPr>
-          </a:p>
-          <a:p>
-            <a:endParaRPr lang="en-IN" i="1" dirty="0" smtClean="0">
-              <a:highlight>
-                <a:srgbClr val="FFFF00"/>
-              </a:highlight>
-            </a:endParaRPr>
-          </a:p>
-          <a:p>
             <a:endParaRPr lang="en-IN" i="1" dirty="0">
               <a:highlight>
                 <a:srgbClr val="FFFF00"/>
@@ -6012,30 +6002,40 @@
             </a:endParaRPr>
           </a:p>
           <a:p>
-            <a:endParaRPr lang="en-IN" i="1" dirty="0" smtClean="0">
+            <a:endParaRPr lang="en-IN" i="1" dirty="0">
               <a:highlight>
                 <a:srgbClr val="FFFF00"/>
               </a:highlight>
             </a:endParaRPr>
           </a:p>
           <a:p>
-            <a:endParaRPr lang="en-IN" i="1" dirty="0" smtClean="0">
+            <a:endParaRPr lang="en-IN" i="1" dirty="0">
               <a:highlight>
                 <a:srgbClr val="FFFF00"/>
               </a:highlight>
             </a:endParaRPr>
           </a:p>
           <a:p>
+            <a:endParaRPr lang="en-IN" i="1" dirty="0">
+              <a:highlight>
+                <a:srgbClr val="FFFF00"/>
+              </a:highlight>
+            </a:endParaRPr>
+          </a:p>
+          <a:p>
+            <a:endParaRPr lang="en-IN" i="1" dirty="0">
+              <a:highlight>
+                <a:srgbClr val="FFFF00"/>
+              </a:highlight>
+            </a:endParaRPr>
+          </a:p>
+          <a:p>
             <a:pPr marL="0" indent="0">
               <a:buNone/>
             </a:pPr>
             <a:r>
-              <a:rPr lang="en-IN" dirty="0" smtClean="0"/>
-              <a:t>All </a:t>
-            </a:r>
-            <a:r>
               <a:rPr lang="en-IN" dirty="0"/>
-              <a:t>the above aspects are addressed and updated by the project team.</a:t>
+              <a:t>All the above aspects are addressed and updated by the project team.</a:t>
             </a:r>
           </a:p>
           <a:p>
@@ -6062,7 +6062,7 @@
           <p:cNvPr id="4" name="Date Placeholder 3">
             <a:extLst>
               <a:ext uri="{FF2B5EF4-FFF2-40B4-BE49-F238E27FC236}">
-                <a16:creationId xmlns:a16="http://schemas.microsoft.com/office/drawing/2014/main" xmlns="" id="{C7827C50-3ED3-2DB6-C227-6784C6CA9E30}"/>
+                <a16:creationId xmlns:a16="http://schemas.microsoft.com/office/drawing/2014/main" id="{C7827C50-3ED3-2DB6-C227-6784C6CA9E30}"/>
               </a:ext>
             </a:extLst>
           </p:cNvPr>
@@ -6080,7 +6080,7 @@
           <a:p>
             <a:fld id="{FEA886FF-1BA7-4533-94E6-869CE1E2970B}" type="datetime1">
               <a:rPr lang="en-IN" smtClean="0"/>
-              <a:t>05/10/26</a:t>
+              <a:t>25-10-2026</a:t>
             </a:fld>
             <a:endParaRPr lang="en-IN" dirty="0"/>
           </a:p>
@@ -6091,7 +6091,7 @@
           <p:cNvPr id="5" name="Footer Placeholder 4">
             <a:extLst>
               <a:ext uri="{FF2B5EF4-FFF2-40B4-BE49-F238E27FC236}">
-                <a16:creationId xmlns:a16="http://schemas.microsoft.com/office/drawing/2014/main" xmlns="" id="{56664170-792F-28F8-1C31-5F7A8D69F97E}"/>
+                <a16:creationId xmlns:a16="http://schemas.microsoft.com/office/drawing/2014/main" id="{56664170-792F-28F8-1C31-5F7A8D69F97E}"/>
               </a:ext>
             </a:extLst>
           </p:cNvPr>
@@ -6119,7 +6119,7 @@
           <p:cNvPr id="6" name="Slide Number Placeholder 5">
             <a:extLst>
               <a:ext uri="{FF2B5EF4-FFF2-40B4-BE49-F238E27FC236}">
-                <a16:creationId xmlns:a16="http://schemas.microsoft.com/office/drawing/2014/main" xmlns="" id="{EE16528B-72DB-0275-6A94-33ABB5CD7075}"/>
+                <a16:creationId xmlns:a16="http://schemas.microsoft.com/office/drawing/2014/main" id="{EE16528B-72DB-0275-6A94-33ABB5CD7075}"/>
               </a:ext>
             </a:extLst>
           </p:cNvPr>
@@ -6183,13 +6183,6 @@
   <p:clrMapOvr>
     <a:masterClrMapping/>
   </p:clrMapOvr>
-  <p:timing>
-    <p:tnLst>
-      <p:par>
-        <p:cTn xmlns:p14="http://schemas.microsoft.com/office/powerpoint/2010/main" id="1" dur="indefinite" restart="never" nodeType="tmRoot"/>
-      </p:par>
-    </p:tnLst>
-  </p:timing>
 </p:sld>
 </file>
 
@@ -6215,7 +6208,7 @@
           <p:cNvPr id="3" name="Content Placeholder 2">
             <a:extLst>
               <a:ext uri="{FF2B5EF4-FFF2-40B4-BE49-F238E27FC236}">
-                <a16:creationId xmlns:a16="http://schemas.microsoft.com/office/drawing/2014/main" xmlns="" id="{4D68A428-04DA-E6A8-7606-5D2FE5F31C52}"/>
+                <a16:creationId xmlns:a16="http://schemas.microsoft.com/office/drawing/2014/main" id="{4D68A428-04DA-E6A8-7606-5D2FE5F31C52}"/>
               </a:ext>
             </a:extLst>
           </p:cNvPr>
@@ -6347,7 +6340,7 @@
           <p:cNvPr id="4" name="object 2">
             <a:extLst>
               <a:ext uri="{FF2B5EF4-FFF2-40B4-BE49-F238E27FC236}">
-                <a16:creationId xmlns:a16="http://schemas.microsoft.com/office/drawing/2014/main" xmlns="" id="{027305EA-516C-11F8-8A54-2BA046094ABC}"/>
+                <a16:creationId xmlns:a16="http://schemas.microsoft.com/office/drawing/2014/main" id="{027305EA-516C-11F8-8A54-2BA046094ABC}"/>
               </a:ext>
             </a:extLst>
           </p:cNvPr>
@@ -6400,7 +6393,7 @@
           <p:cNvPr id="7" name="Date Placeholder 6">
             <a:extLst>
               <a:ext uri="{FF2B5EF4-FFF2-40B4-BE49-F238E27FC236}">
-                <a16:creationId xmlns:a16="http://schemas.microsoft.com/office/drawing/2014/main" xmlns="" id="{779E6AA7-AE20-8A91-BA42-261BF76A2F8B}"/>
+                <a16:creationId xmlns:a16="http://schemas.microsoft.com/office/drawing/2014/main" id="{779E6AA7-AE20-8A91-BA42-261BF76A2F8B}"/>
               </a:ext>
             </a:extLst>
           </p:cNvPr>
@@ -6418,7 +6411,7 @@
           <a:p>
             <a:fld id="{61736562-4E3F-4038-A291-A7AE35CC3E6A}" type="datetime1">
               <a:rPr lang="en-IN" smtClean="0"/>
-              <a:t>05/10/26</a:t>
+              <a:t>25-10-2026</a:t>
             </a:fld>
             <a:endParaRPr lang="en-IN"/>
           </a:p>
@@ -6429,7 +6422,7 @@
           <p:cNvPr id="8" name="Footer Placeholder 7">
             <a:extLst>
               <a:ext uri="{FF2B5EF4-FFF2-40B4-BE49-F238E27FC236}">
-                <a16:creationId xmlns:a16="http://schemas.microsoft.com/office/drawing/2014/main" xmlns="" id="{B77FE434-77F0-B8BE-9198-66090332F3F0}"/>
+                <a16:creationId xmlns:a16="http://schemas.microsoft.com/office/drawing/2014/main" id="{B77FE434-77F0-B8BE-9198-66090332F3F0}"/>
               </a:ext>
             </a:extLst>
           </p:cNvPr>
@@ -6457,7 +6450,7 @@
           <p:cNvPr id="9" name="Slide Number Placeholder 8">
             <a:extLst>
               <a:ext uri="{FF2B5EF4-FFF2-40B4-BE49-F238E27FC236}">
-                <a16:creationId xmlns:a16="http://schemas.microsoft.com/office/drawing/2014/main" xmlns="" id="{5AD6A9DA-AEE9-F6FE-EFA8-06396314F7E6}"/>
+                <a16:creationId xmlns:a16="http://schemas.microsoft.com/office/drawing/2014/main" id="{5AD6A9DA-AEE9-F6FE-EFA8-06396314F7E6}"/>
               </a:ext>
             </a:extLst>
           </p:cNvPr>
@@ -6491,13 +6484,6 @@
   <p:clrMapOvr>
     <a:masterClrMapping/>
   </p:clrMapOvr>
-  <p:timing>
-    <p:tnLst>
-      <p:par>
-        <p:cTn xmlns:p14="http://schemas.microsoft.com/office/powerpoint/2010/main" id="1" dur="indefinite" restart="never" nodeType="tmRoot"/>
-      </p:par>
-    </p:tnLst>
-  </p:timing>
 </p:sld>
 </file>
 
@@ -6509,7 +6495,7 @@
         <p:cNvPr id="1" name="">
           <a:extLst>
             <a:ext uri="{FF2B5EF4-FFF2-40B4-BE49-F238E27FC236}">
-              <a16:creationId xmlns:a16="http://schemas.microsoft.com/office/drawing/2014/main" xmlns="" id="{30BD95E8-8D7C-F548-8B75-23C3B2B15B19}"/>
+              <a16:creationId xmlns:a16="http://schemas.microsoft.com/office/drawing/2014/main" id="{30BD95E8-8D7C-F548-8B75-23C3B2B15B19}"/>
             </a:ext>
           </a:extLst>
         </p:cNvPr>
@@ -6529,7 +6515,7 @@
           <p:cNvPr id="3" name="Content Placeholder 2">
             <a:extLst>
               <a:ext uri="{FF2B5EF4-FFF2-40B4-BE49-F238E27FC236}">
-                <a16:creationId xmlns:a16="http://schemas.microsoft.com/office/drawing/2014/main" xmlns="" id="{35DDED8F-1EBD-2E10-598E-0CA3F56F05DF}"/>
+                <a16:creationId xmlns:a16="http://schemas.microsoft.com/office/drawing/2014/main" id="{35DDED8F-1EBD-2E10-598E-0CA3F56F05DF}"/>
               </a:ext>
             </a:extLst>
           </p:cNvPr>
@@ -6661,7 +6647,7 @@
           <p:cNvPr id="4" name="object 2">
             <a:extLst>
               <a:ext uri="{FF2B5EF4-FFF2-40B4-BE49-F238E27FC236}">
-                <a16:creationId xmlns:a16="http://schemas.microsoft.com/office/drawing/2014/main" xmlns="" id="{156C6ACB-BF9E-DB99-B99C-4896C652737E}"/>
+                <a16:creationId xmlns:a16="http://schemas.microsoft.com/office/drawing/2014/main" id="{156C6ACB-BF9E-DB99-B99C-4896C652737E}"/>
               </a:ext>
             </a:extLst>
           </p:cNvPr>
@@ -6714,7 +6700,7 @@
           <p:cNvPr id="2" name="Date Placeholder 1">
             <a:extLst>
               <a:ext uri="{FF2B5EF4-FFF2-40B4-BE49-F238E27FC236}">
-                <a16:creationId xmlns:a16="http://schemas.microsoft.com/office/drawing/2014/main" xmlns="" id="{7C3D067F-DF0A-3BD2-0B9E-C22E39B7F8C0}"/>
+                <a16:creationId xmlns:a16="http://schemas.microsoft.com/office/drawing/2014/main" id="{7C3D067F-DF0A-3BD2-0B9E-C22E39B7F8C0}"/>
               </a:ext>
             </a:extLst>
           </p:cNvPr>
@@ -6732,7 +6718,7 @@
           <a:p>
             <a:fld id="{22261D5D-2F82-4210-B67C-C3AADE7FED47}" type="datetime1">
               <a:rPr lang="en-IN" smtClean="0"/>
-              <a:t>05/10/26</a:t>
+              <a:t>25-10-2026</a:t>
             </a:fld>
             <a:endParaRPr lang="en-IN"/>
           </a:p>
@@ -6743,7 +6729,7 @@
           <p:cNvPr id="5" name="Footer Placeholder 4">
             <a:extLst>
               <a:ext uri="{FF2B5EF4-FFF2-40B4-BE49-F238E27FC236}">
-                <a16:creationId xmlns:a16="http://schemas.microsoft.com/office/drawing/2014/main" xmlns="" id="{E1EFD8C3-C2D0-4BBB-7FD8-43FE2C084A64}"/>
+                <a16:creationId xmlns:a16="http://schemas.microsoft.com/office/drawing/2014/main" id="{E1EFD8C3-C2D0-4BBB-7FD8-43FE2C084A64}"/>
               </a:ext>
             </a:extLst>
           </p:cNvPr>
@@ -6771,7 +6757,7 @@
           <p:cNvPr id="6" name="Slide Number Placeholder 5">
             <a:extLst>
               <a:ext uri="{FF2B5EF4-FFF2-40B4-BE49-F238E27FC236}">
-                <a16:creationId xmlns:a16="http://schemas.microsoft.com/office/drawing/2014/main" xmlns="" id="{8BB9991A-41D4-F0AB-EF39-ACE70C817D43}"/>
+                <a16:creationId xmlns:a16="http://schemas.microsoft.com/office/drawing/2014/main" id="{8BB9991A-41D4-F0AB-EF39-ACE70C817D43}"/>
               </a:ext>
             </a:extLst>
           </p:cNvPr>
@@ -6805,13 +6791,6 @@
   <p:clrMapOvr>
     <a:masterClrMapping/>
   </p:clrMapOvr>
-  <p:timing>
-    <p:tnLst>
-      <p:par>
-        <p:cTn xmlns:p14="http://schemas.microsoft.com/office/powerpoint/2010/main" id="1" dur="indefinite" restart="never" nodeType="tmRoot"/>
-      </p:par>
-    </p:tnLst>
-  </p:timing>
 </p:sld>
 </file>
 
@@ -6823,7 +6802,7 @@
         <p:cNvPr id="1" name="">
           <a:extLst>
             <a:ext uri="{FF2B5EF4-FFF2-40B4-BE49-F238E27FC236}">
-              <a16:creationId xmlns:a16="http://schemas.microsoft.com/office/drawing/2014/main" xmlns="" id="{8FF0AE58-8206-476A-BECC-A1ADC0EA154A}"/>
+              <a16:creationId xmlns:a16="http://schemas.microsoft.com/office/drawing/2014/main" id="{8FF0AE58-8206-476A-BECC-A1ADC0EA154A}"/>
             </a:ext>
           </a:extLst>
         </p:cNvPr>
@@ -6843,7 +6822,7 @@
           <p:cNvPr id="4" name="object 2">
             <a:extLst>
               <a:ext uri="{FF2B5EF4-FFF2-40B4-BE49-F238E27FC236}">
-                <a16:creationId xmlns:a16="http://schemas.microsoft.com/office/drawing/2014/main" xmlns="" id="{435FB437-6170-6BA2-1A38-A902855A3E61}"/>
+                <a16:creationId xmlns:a16="http://schemas.microsoft.com/office/drawing/2014/main" id="{435FB437-6170-6BA2-1A38-A902855A3E61}"/>
               </a:ext>
             </a:extLst>
           </p:cNvPr>
@@ -6896,7 +6875,7 @@
           <p:cNvPr id="8" name="Date Placeholder 7">
             <a:extLst>
               <a:ext uri="{FF2B5EF4-FFF2-40B4-BE49-F238E27FC236}">
-                <a16:creationId xmlns:a16="http://schemas.microsoft.com/office/drawing/2014/main" xmlns="" id="{913BC6E0-D294-E70D-8B27-13FBFEE5E6F7}"/>
+                <a16:creationId xmlns:a16="http://schemas.microsoft.com/office/drawing/2014/main" id="{913BC6E0-D294-E70D-8B27-13FBFEE5E6F7}"/>
               </a:ext>
             </a:extLst>
           </p:cNvPr>
@@ -6914,7 +6893,7 @@
           <a:p>
             <a:fld id="{E919193B-09C0-4C85-858C-650926A9B146}" type="datetime1">
               <a:rPr lang="en-IN" smtClean="0"/>
-              <a:t>05/10/26</a:t>
+              <a:t>25-10-2026</a:t>
             </a:fld>
             <a:endParaRPr lang="en-IN"/>
           </a:p>
@@ -6925,7 +6904,7 @@
           <p:cNvPr id="9" name="Footer Placeholder 8">
             <a:extLst>
               <a:ext uri="{FF2B5EF4-FFF2-40B4-BE49-F238E27FC236}">
-                <a16:creationId xmlns:a16="http://schemas.microsoft.com/office/drawing/2014/main" xmlns="" id="{1F284BA2-3334-3EC1-0E81-4C909589729F}"/>
+                <a16:creationId xmlns:a16="http://schemas.microsoft.com/office/drawing/2014/main" id="{1F284BA2-3334-3EC1-0E81-4C909589729F}"/>
               </a:ext>
             </a:extLst>
           </p:cNvPr>
@@ -6953,7 +6932,7 @@
           <p:cNvPr id="10" name="Slide Number Placeholder 9">
             <a:extLst>
               <a:ext uri="{FF2B5EF4-FFF2-40B4-BE49-F238E27FC236}">
-                <a16:creationId xmlns:a16="http://schemas.microsoft.com/office/drawing/2014/main" xmlns="" id="{5A8F14EB-D02F-8EDE-87F4-A3F7E8D20C44}"/>
+                <a16:creationId xmlns:a16="http://schemas.microsoft.com/office/drawing/2014/main" id="{5A8F14EB-D02F-8EDE-87F4-A3F7E8D20C44}"/>
               </a:ext>
             </a:extLst>
           </p:cNvPr>
@@ -6996,16 +6975,46 @@
                 <a:tableStyleId>{5C22544A-7EE6-4342-B048-85BDC9FD1C3A}</a:tableStyleId>
               </a:tblPr>
               <a:tblGrid>
-                <a:gridCol w="2057400"/>
-                <a:gridCol w="2057400"/>
-                <a:gridCol w="2240280"/>
-                <a:gridCol w="2514600"/>
-                <a:gridCol w="2560320"/>
+                <a:gridCol w="2057400">
+                  <a:extLst>
+                    <a:ext uri="{9D8B030D-6E8A-4147-A177-3AD203B41FA5}">
+                      <a16:colId xmlns:a16="http://schemas.microsoft.com/office/drawing/2014/main" val="20000"/>
+                    </a:ext>
+                  </a:extLst>
+                </a:gridCol>
+                <a:gridCol w="2057400">
+                  <a:extLst>
+                    <a:ext uri="{9D8B030D-6E8A-4147-A177-3AD203B41FA5}">
+                      <a16:colId xmlns:a16="http://schemas.microsoft.com/office/drawing/2014/main" val="20001"/>
+                    </a:ext>
+                  </a:extLst>
+                </a:gridCol>
+                <a:gridCol w="2240280">
+                  <a:extLst>
+                    <a:ext uri="{9D8B030D-6E8A-4147-A177-3AD203B41FA5}">
+                      <a16:colId xmlns:a16="http://schemas.microsoft.com/office/drawing/2014/main" val="20002"/>
+                    </a:ext>
+                  </a:extLst>
+                </a:gridCol>
+                <a:gridCol w="2514600">
+                  <a:extLst>
+                    <a:ext uri="{9D8B030D-6E8A-4147-A177-3AD203B41FA5}">
+                      <a16:colId xmlns:a16="http://schemas.microsoft.com/office/drawing/2014/main" val="20003"/>
+                    </a:ext>
+                  </a:extLst>
+                </a:gridCol>
+                <a:gridCol w="2560320">
+                  <a:extLst>
+                    <a:ext uri="{9D8B030D-6E8A-4147-A177-3AD203B41FA5}">
+                      <a16:colId xmlns:a16="http://schemas.microsoft.com/office/drawing/2014/main" val="20004"/>
+                    </a:ext>
+                  </a:extLst>
+                </a:gridCol>
               </a:tblGrid>
               <a:tr h="792480">
                 <a:tc>
                   <a:txBody>
-                    <a:bodyPr wrap="square"/>
+                    <a:bodyPr/>
                     <a:lstStyle/>
                     <a:p>
                       <a:pPr>
@@ -7031,7 +7040,7 @@
                 </a:tc>
                 <a:tc>
                   <a:txBody>
-                    <a:bodyPr wrap="square"/>
+                    <a:bodyPr/>
                     <a:lstStyle/>
                     <a:p>
                       <a:pPr>
@@ -7057,7 +7066,7 @@
                 </a:tc>
                 <a:tc>
                   <a:txBody>
-                    <a:bodyPr wrap="square"/>
+                    <a:bodyPr/>
                     <a:lstStyle/>
                     <a:p>
                       <a:pPr>
@@ -7083,7 +7092,7 @@
                 </a:tc>
                 <a:tc>
                   <a:txBody>
-                    <a:bodyPr wrap="square"/>
+                    <a:bodyPr/>
                     <a:lstStyle/>
                     <a:p>
                       <a:pPr>
@@ -7109,7 +7118,7 @@
                 </a:tc>
                 <a:tc>
                   <a:txBody>
-                    <a:bodyPr wrap="square"/>
+                    <a:bodyPr/>
                     <a:lstStyle/>
                     <a:p>
                       <a:pPr>
@@ -7133,11 +7142,16 @@
                     </a:solidFill>
                   </a:tcPr>
                 </a:tc>
+                <a:extLst>
+                  <a:ext uri="{0D108BD9-81ED-4DB2-BD59-A6C34878D82A}">
+                    <a16:rowId xmlns:a16="http://schemas.microsoft.com/office/drawing/2014/main" val="10000"/>
+                  </a:ext>
+                </a:extLst>
               </a:tr>
               <a:tr h="792480">
                 <a:tc>
                   <a:txBody>
-                    <a:bodyPr wrap="square"/>
+                    <a:bodyPr/>
                     <a:lstStyle/>
                     <a:p>
                       <a:pPr>
@@ -7163,7 +7177,7 @@
                 </a:tc>
                 <a:tc>
                   <a:txBody>
-                    <a:bodyPr wrap="square"/>
+                    <a:bodyPr/>
                     <a:lstStyle/>
                     <a:p>
                       <a:pPr>
@@ -7189,7 +7203,7 @@
                 </a:tc>
                 <a:tc>
                   <a:txBody>
-                    <a:bodyPr wrap="square"/>
+                    <a:bodyPr/>
                     <a:lstStyle/>
                     <a:p>
                       <a:pPr>
@@ -7215,7 +7229,7 @@
                 </a:tc>
                 <a:tc>
                   <a:txBody>
-                    <a:bodyPr wrap="square"/>
+                    <a:bodyPr/>
                     <a:lstStyle/>
                     <a:p>
                       <a:pPr>
@@ -7256,7 +7270,7 @@
                 </a:tc>
                 <a:tc>
                   <a:txBody>
-                    <a:bodyPr wrap="square"/>
+                    <a:bodyPr/>
                     <a:lstStyle/>
                     <a:p>
                       <a:pPr>
@@ -7280,11 +7294,16 @@
                     </a:solidFill>
                   </a:tcPr>
                 </a:tc>
+                <a:extLst>
+                  <a:ext uri="{0D108BD9-81ED-4DB2-BD59-A6C34878D82A}">
+                    <a16:rowId xmlns:a16="http://schemas.microsoft.com/office/drawing/2014/main" val="10001"/>
+                  </a:ext>
+                </a:extLst>
               </a:tr>
               <a:tr h="792480">
                 <a:tc>
                   <a:txBody>
-                    <a:bodyPr wrap="square"/>
+                    <a:bodyPr/>
                     <a:lstStyle/>
                     <a:p>
                       <a:pPr>
@@ -7310,7 +7329,7 @@
                 </a:tc>
                 <a:tc>
                   <a:txBody>
-                    <a:bodyPr wrap="square"/>
+                    <a:bodyPr/>
                     <a:lstStyle/>
                     <a:p>
                       <a:pPr>
@@ -7336,7 +7355,7 @@
                 </a:tc>
                 <a:tc>
                   <a:txBody>
-                    <a:bodyPr wrap="square"/>
+                    <a:bodyPr/>
                     <a:lstStyle/>
                     <a:p>
                       <a:pPr>
@@ -7362,7 +7381,7 @@
                 </a:tc>
                 <a:tc>
                   <a:txBody>
-                    <a:bodyPr wrap="square"/>
+                    <a:bodyPr/>
                     <a:lstStyle/>
                     <a:p>
                       <a:pPr>
@@ -7403,7 +7422,7 @@
                 </a:tc>
                 <a:tc>
                   <a:txBody>
-                    <a:bodyPr wrap="square"/>
+                    <a:bodyPr/>
                     <a:lstStyle/>
                     <a:p>
                       <a:pPr>
@@ -7427,11 +7446,16 @@
                     </a:solidFill>
                   </a:tcPr>
                 </a:tc>
+                <a:extLst>
+                  <a:ext uri="{0D108BD9-81ED-4DB2-BD59-A6C34878D82A}">
+                    <a16:rowId xmlns:a16="http://schemas.microsoft.com/office/drawing/2014/main" val="10002"/>
+                  </a:ext>
+                </a:extLst>
               </a:tr>
               <a:tr h="792480">
                 <a:tc>
                   <a:txBody>
-                    <a:bodyPr wrap="square"/>
+                    <a:bodyPr/>
                     <a:lstStyle/>
                     <a:p>
                       <a:pPr>
@@ -7457,7 +7481,7 @@
                 </a:tc>
                 <a:tc>
                   <a:txBody>
-                    <a:bodyPr wrap="square"/>
+                    <a:bodyPr/>
                     <a:lstStyle/>
                     <a:p>
                       <a:pPr>
@@ -7483,7 +7507,7 @@
                 </a:tc>
                 <a:tc>
                   <a:txBody>
-                    <a:bodyPr wrap="square"/>
+                    <a:bodyPr/>
                     <a:lstStyle/>
                     <a:p>
                       <a:pPr>
@@ -7509,7 +7533,7 @@
                 </a:tc>
                 <a:tc>
                   <a:txBody>
-                    <a:bodyPr wrap="square"/>
+                    <a:bodyPr/>
                     <a:lstStyle/>
                     <a:p>
                       <a:pPr>
@@ -7550,7 +7574,7 @@
                 </a:tc>
                 <a:tc>
                   <a:txBody>
-                    <a:bodyPr wrap="square"/>
+                    <a:bodyPr/>
                     <a:lstStyle/>
                     <a:p>
                       <a:pPr>
@@ -7574,11 +7598,16 @@
                     </a:solidFill>
                   </a:tcPr>
                 </a:tc>
+                <a:extLst>
+                  <a:ext uri="{0D108BD9-81ED-4DB2-BD59-A6C34878D82A}">
+                    <a16:rowId xmlns:a16="http://schemas.microsoft.com/office/drawing/2014/main" val="10003"/>
+                  </a:ext>
+                </a:extLst>
               </a:tr>
               <a:tr h="792480">
                 <a:tc>
                   <a:txBody>
-                    <a:bodyPr wrap="square"/>
+                    <a:bodyPr/>
                     <a:lstStyle/>
                     <a:p>
                       <a:pPr>
@@ -7604,7 +7633,7 @@
                 </a:tc>
                 <a:tc>
                   <a:txBody>
-                    <a:bodyPr wrap="square"/>
+                    <a:bodyPr/>
                     <a:lstStyle/>
                     <a:p>
                       <a:pPr>
@@ -7630,7 +7659,7 @@
                 </a:tc>
                 <a:tc>
                   <a:txBody>
-                    <a:bodyPr wrap="square"/>
+                    <a:bodyPr/>
                     <a:lstStyle/>
                     <a:p>
                       <a:pPr>
@@ -7656,7 +7685,7 @@
                 </a:tc>
                 <a:tc>
                   <a:txBody>
-                    <a:bodyPr wrap="square"/>
+                    <a:bodyPr/>
                     <a:lstStyle/>
                     <a:p>
                       <a:pPr>
@@ -7697,7 +7726,7 @@
                 </a:tc>
                 <a:tc>
                   <a:txBody>
-                    <a:bodyPr wrap="square"/>
+                    <a:bodyPr/>
                     <a:lstStyle/>
                     <a:p>
                       <a:pPr>
@@ -7721,11 +7750,16 @@
                     </a:solidFill>
                   </a:tcPr>
                 </a:tc>
+                <a:extLst>
+                  <a:ext uri="{0D108BD9-81ED-4DB2-BD59-A6C34878D82A}">
+                    <a16:rowId xmlns:a16="http://schemas.microsoft.com/office/drawing/2014/main" val="10004"/>
+                  </a:ext>
+                </a:extLst>
               </a:tr>
               <a:tr h="792480">
                 <a:tc>
                   <a:txBody>
-                    <a:bodyPr wrap="square"/>
+                    <a:bodyPr/>
                     <a:lstStyle/>
                     <a:p>
                       <a:pPr>
@@ -7751,7 +7785,7 @@
                 </a:tc>
                 <a:tc>
                   <a:txBody>
-                    <a:bodyPr wrap="square"/>
+                    <a:bodyPr/>
                     <a:lstStyle/>
                     <a:p>
                       <a:pPr>
@@ -7777,7 +7811,7 @@
                 </a:tc>
                 <a:tc>
                   <a:txBody>
-                    <a:bodyPr wrap="square"/>
+                    <a:bodyPr/>
                     <a:lstStyle/>
                     <a:p>
                       <a:pPr>
@@ -7803,7 +7837,7 @@
                 </a:tc>
                 <a:tc>
                   <a:txBody>
-                    <a:bodyPr wrap="square"/>
+                    <a:bodyPr/>
                     <a:lstStyle/>
                     <a:p>
                       <a:pPr>
@@ -7844,7 +7878,7 @@
                 </a:tc>
                 <a:tc>
                   <a:txBody>
-                    <a:bodyPr wrap="square"/>
+                    <a:bodyPr/>
                     <a:lstStyle/>
                     <a:p>
                       <a:pPr>
@@ -7868,6 +7902,11 @@
                     </a:solidFill>
                   </a:tcPr>
                 </a:tc>
+                <a:extLst>
+                  <a:ext uri="{0D108BD9-81ED-4DB2-BD59-A6C34878D82A}">
+                    <a16:rowId xmlns:a16="http://schemas.microsoft.com/office/drawing/2014/main" val="10005"/>
+                  </a:ext>
+                </a:extLst>
               </a:tr>
             </a:tbl>
           </a:graphicData>
@@ -7894,7 +7933,7 @@
         <p:cNvPr id="1" name="">
           <a:extLst>
             <a:ext uri="{FF2B5EF4-FFF2-40B4-BE49-F238E27FC236}">
-              <a16:creationId xmlns:a16="http://schemas.microsoft.com/office/drawing/2014/main" xmlns="" id="{9FD64C5E-26B3-2EE9-895A-F822E4C49ED0}"/>
+              <a16:creationId xmlns:a16="http://schemas.microsoft.com/office/drawing/2014/main" id="{9FD64C5E-26B3-2EE9-895A-F822E4C49ED0}"/>
             </a:ext>
           </a:extLst>
         </p:cNvPr>
@@ -7914,7 +7953,7 @@
           <p:cNvPr id="3" name="Content Placeholder 2">
             <a:extLst>
               <a:ext uri="{FF2B5EF4-FFF2-40B4-BE49-F238E27FC236}">
-                <a16:creationId xmlns:a16="http://schemas.microsoft.com/office/drawing/2014/main" xmlns="" id="{F07F8AC8-6380-9217-CA4C-1FBF1C25C60E}"/>
+                <a16:creationId xmlns:a16="http://schemas.microsoft.com/office/drawing/2014/main" id="{F07F8AC8-6380-9217-CA4C-1FBF1C25C60E}"/>
               </a:ext>
             </a:extLst>
           </p:cNvPr>
@@ -8046,7 +8085,7 @@
           <p:cNvPr id="4" name="object 2">
             <a:extLst>
               <a:ext uri="{FF2B5EF4-FFF2-40B4-BE49-F238E27FC236}">
-                <a16:creationId xmlns:a16="http://schemas.microsoft.com/office/drawing/2014/main" xmlns="" id="{2E07AC55-BA5E-4123-39E6-B79860C6C9EE}"/>
+                <a16:creationId xmlns:a16="http://schemas.microsoft.com/office/drawing/2014/main" id="{2E07AC55-BA5E-4123-39E6-B79860C6C9EE}"/>
               </a:ext>
             </a:extLst>
           </p:cNvPr>
@@ -8099,7 +8138,7 @@
           <p:cNvPr id="2" name="Date Placeholder 1">
             <a:extLst>
               <a:ext uri="{FF2B5EF4-FFF2-40B4-BE49-F238E27FC236}">
-                <a16:creationId xmlns:a16="http://schemas.microsoft.com/office/drawing/2014/main" xmlns="" id="{A2430A72-466B-CBDE-2F02-635BA91A98AF}"/>
+                <a16:creationId xmlns:a16="http://schemas.microsoft.com/office/drawing/2014/main" id="{A2430A72-466B-CBDE-2F02-635BA91A98AF}"/>
               </a:ext>
             </a:extLst>
           </p:cNvPr>
@@ -8117,7 +8156,7 @@
           <a:p>
             <a:fld id="{49AE986A-8308-4C4E-A0F3-DDD9B5B25762}" type="datetime1">
               <a:rPr lang="en-IN" smtClean="0"/>
-              <a:t>05/10/26</a:t>
+              <a:t>25-10-2026</a:t>
             </a:fld>
             <a:endParaRPr lang="en-IN"/>
           </a:p>
@@ -8128,7 +8167,7 @@
           <p:cNvPr id="5" name="Footer Placeholder 4">
             <a:extLst>
               <a:ext uri="{FF2B5EF4-FFF2-40B4-BE49-F238E27FC236}">
-                <a16:creationId xmlns:a16="http://schemas.microsoft.com/office/drawing/2014/main" xmlns="" id="{1711DDA3-7A7C-1F61-1795-3A01ED678FAB}"/>
+                <a16:creationId xmlns:a16="http://schemas.microsoft.com/office/drawing/2014/main" id="{1711DDA3-7A7C-1F61-1795-3A01ED678FAB}"/>
               </a:ext>
             </a:extLst>
           </p:cNvPr>
@@ -8156,7 +8195,7 @@
           <p:cNvPr id="6" name="Slide Number Placeholder 5">
             <a:extLst>
               <a:ext uri="{FF2B5EF4-FFF2-40B4-BE49-F238E27FC236}">
-                <a16:creationId xmlns:a16="http://schemas.microsoft.com/office/drawing/2014/main" xmlns="" id="{D94E3226-1DB1-3A4D-CE37-4A2AD48EF1F1}"/>
+                <a16:creationId xmlns:a16="http://schemas.microsoft.com/office/drawing/2014/main" id="{D94E3226-1DB1-3A4D-CE37-4A2AD48EF1F1}"/>
               </a:ext>
             </a:extLst>
           </p:cNvPr>
@@ -8201,7 +8240,7 @@
         <p:cNvPr id="1" name="">
           <a:extLst>
             <a:ext uri="{FF2B5EF4-FFF2-40B4-BE49-F238E27FC236}">
-              <a16:creationId xmlns:a16="http://schemas.microsoft.com/office/drawing/2014/main" xmlns="" id="{FFF50AAC-0156-D6F5-7153-C7919999408B}"/>
+              <a16:creationId xmlns:a16="http://schemas.microsoft.com/office/drawing/2014/main" id="{FFF50AAC-0156-D6F5-7153-C7919999408B}"/>
             </a:ext>
           </a:extLst>
         </p:cNvPr>
@@ -8221,7 +8260,7 @@
           <p:cNvPr id="3" name="Content Placeholder 2">
             <a:extLst>
               <a:ext uri="{FF2B5EF4-FFF2-40B4-BE49-F238E27FC236}">
-                <a16:creationId xmlns:a16="http://schemas.microsoft.com/office/drawing/2014/main" xmlns="" id="{6283ADE1-559A-2DC2-A801-6A915E106C60}"/>
+                <a16:creationId xmlns:a16="http://schemas.microsoft.com/office/drawing/2014/main" id="{6283ADE1-559A-2DC2-A801-6A915E106C60}"/>
               </a:ext>
             </a:extLst>
           </p:cNvPr>
@@ -8376,7 +8415,7 @@
           <p:cNvPr id="4" name="object 2">
             <a:extLst>
               <a:ext uri="{FF2B5EF4-FFF2-40B4-BE49-F238E27FC236}">
-                <a16:creationId xmlns:a16="http://schemas.microsoft.com/office/drawing/2014/main" xmlns="" id="{22BADD22-870A-4D8F-B788-CCCD5C223F9A}"/>
+                <a16:creationId xmlns:a16="http://schemas.microsoft.com/office/drawing/2014/main" id="{22BADD22-870A-4D8F-B788-CCCD5C223F9A}"/>
               </a:ext>
             </a:extLst>
           </p:cNvPr>
@@ -8429,7 +8468,7 @@
           <p:cNvPr id="2" name="Date Placeholder 1">
             <a:extLst>
               <a:ext uri="{FF2B5EF4-FFF2-40B4-BE49-F238E27FC236}">
-                <a16:creationId xmlns:a16="http://schemas.microsoft.com/office/drawing/2014/main" xmlns="" id="{1BE4F0EB-E8F1-14D8-E22A-38E83F9BFA94}"/>
+                <a16:creationId xmlns:a16="http://schemas.microsoft.com/office/drawing/2014/main" id="{1BE4F0EB-E8F1-14D8-E22A-38E83F9BFA94}"/>
               </a:ext>
             </a:extLst>
           </p:cNvPr>
@@ -8450,7 +8489,7 @@
                 <a:latin typeface="Times New Roman" panose="02020603050405020304" pitchFamily="18" charset="0"/>
                 <a:cs typeface="Times New Roman" panose="02020603050405020304" pitchFamily="18" charset="0"/>
               </a:rPr>
-              <a:t>05/10/26</a:t>
+              <a:t>25-10-2026</a:t>
             </a:fld>
             <a:endParaRPr lang="en-IN">
               <a:latin typeface="Times New Roman" panose="02020603050405020304" pitchFamily="18" charset="0"/>
@@ -8464,7 +8503,7 @@
           <p:cNvPr id="5" name="Footer Placeholder 4">
             <a:extLst>
               <a:ext uri="{FF2B5EF4-FFF2-40B4-BE49-F238E27FC236}">
-                <a16:creationId xmlns:a16="http://schemas.microsoft.com/office/drawing/2014/main" xmlns="" id="{76D8B93F-BA73-08B5-E0DD-D434FA25B92B}"/>
+                <a16:creationId xmlns:a16="http://schemas.microsoft.com/office/drawing/2014/main" id="{76D8B93F-BA73-08B5-E0DD-D434FA25B92B}"/>
               </a:ext>
             </a:extLst>
           </p:cNvPr>
@@ -8495,7 +8534,7 @@
           <p:cNvPr id="6" name="Slide Number Placeholder 5">
             <a:extLst>
               <a:ext uri="{FF2B5EF4-FFF2-40B4-BE49-F238E27FC236}">
-                <a16:creationId xmlns:a16="http://schemas.microsoft.com/office/drawing/2014/main" xmlns="" id="{E6BABF72-E9F9-626A-63CD-EA20C0714ABC}"/>
+                <a16:creationId xmlns:a16="http://schemas.microsoft.com/office/drawing/2014/main" id="{E6BABF72-E9F9-626A-63CD-EA20C0714ABC}"/>
               </a:ext>
             </a:extLst>
           </p:cNvPr>
@@ -8530,7 +8569,7 @@
           <p:cNvPr id="7" name="TextBox 6">
             <a:extLst>
               <a:ext uri="{FF2B5EF4-FFF2-40B4-BE49-F238E27FC236}">
-                <a16:creationId xmlns:a16="http://schemas.microsoft.com/office/drawing/2014/main" xmlns="" id="{82632EBB-2D05-8D00-7F98-43CBAFAF06ED}"/>
+                <a16:creationId xmlns:a16="http://schemas.microsoft.com/office/drawing/2014/main" id="{82632EBB-2D05-8D00-7F98-43CBAFAF06ED}"/>
               </a:ext>
             </a:extLst>
           </p:cNvPr>
@@ -8595,7 +8634,7 @@
           <p:cNvPr id="8" name="Picture 7" descr="3 The UN 17 Sustainable Development Goals (SDGs), implemented by all... | Download Scientific Diagram">
             <a:extLst>
               <a:ext uri="{FF2B5EF4-FFF2-40B4-BE49-F238E27FC236}">
-                <a16:creationId xmlns:a16="http://schemas.microsoft.com/office/drawing/2014/main" xmlns="" id="{36180A9B-AA72-E2D6-8362-4CDF7058D84A}"/>
+                <a16:creationId xmlns:a16="http://schemas.microsoft.com/office/drawing/2014/main" id="{36180A9B-AA72-E2D6-8362-4CDF7058D84A}"/>
               </a:ext>
             </a:extLst>
           </p:cNvPr>
@@ -8625,7 +8664,7 @@
           <p:cNvPr id="9" name="Picture 8" descr="What are Technology Readiness Levels (TRL)? - TWI">
             <a:extLst>
               <a:ext uri="{FF2B5EF4-FFF2-40B4-BE49-F238E27FC236}">
-                <a16:creationId xmlns:a16="http://schemas.microsoft.com/office/drawing/2014/main" xmlns="" id="{D1491C9C-07B3-89C3-5FA0-72C9F44F30AC}"/>
+                <a16:creationId xmlns:a16="http://schemas.microsoft.com/office/drawing/2014/main" id="{D1491C9C-07B3-89C3-5FA0-72C9F44F30AC}"/>
               </a:ext>
             </a:extLst>
           </p:cNvPr>
@@ -8671,7 +8710,7 @@
         <p:cNvPr id="1" name="">
           <a:extLst>
             <a:ext uri="{FF2B5EF4-FFF2-40B4-BE49-F238E27FC236}">
-              <a16:creationId xmlns:a16="http://schemas.microsoft.com/office/drawing/2014/main" xmlns="" id="{08D49C0F-2490-21B4-8186-6F75540ACED9}"/>
+              <a16:creationId xmlns:a16="http://schemas.microsoft.com/office/drawing/2014/main" id="{08D49C0F-2490-21B4-8186-6F75540ACED9}"/>
             </a:ext>
           </a:extLst>
         </p:cNvPr>
@@ -8691,7 +8730,7 @@
           <p:cNvPr id="3" name="Content Placeholder 2">
             <a:extLst>
               <a:ext uri="{FF2B5EF4-FFF2-40B4-BE49-F238E27FC236}">
-                <a16:creationId xmlns:a16="http://schemas.microsoft.com/office/drawing/2014/main" xmlns="" id="{5BFBB131-7217-3694-F593-4021591CC64F}"/>
+                <a16:creationId xmlns:a16="http://schemas.microsoft.com/office/drawing/2014/main" id="{5BFBB131-7217-3694-F593-4021591CC64F}"/>
               </a:ext>
             </a:extLst>
           </p:cNvPr>
@@ -8738,7 +8777,7 @@
           <p:cNvPr id="4" name="object 2">
             <a:extLst>
               <a:ext uri="{FF2B5EF4-FFF2-40B4-BE49-F238E27FC236}">
-                <a16:creationId xmlns:a16="http://schemas.microsoft.com/office/drawing/2014/main" xmlns="" id="{5DE9EA00-8D77-8DC9-1AE3-8B6FD1AF6BCC}"/>
+                <a16:creationId xmlns:a16="http://schemas.microsoft.com/office/drawing/2014/main" id="{5DE9EA00-8D77-8DC9-1AE3-8B6FD1AF6BCC}"/>
               </a:ext>
             </a:extLst>
           </p:cNvPr>
@@ -8791,7 +8830,7 @@
           <p:cNvPr id="2" name="Date Placeholder 1">
             <a:extLst>
               <a:ext uri="{FF2B5EF4-FFF2-40B4-BE49-F238E27FC236}">
-                <a16:creationId xmlns:a16="http://schemas.microsoft.com/office/drawing/2014/main" xmlns="" id="{3B40592E-46EE-B4F2-7D01-D3568C2F685A}"/>
+                <a16:creationId xmlns:a16="http://schemas.microsoft.com/office/drawing/2014/main" id="{3B40592E-46EE-B4F2-7D01-D3568C2F685A}"/>
               </a:ext>
             </a:extLst>
           </p:cNvPr>
@@ -8812,7 +8851,7 @@
                 <a:latin typeface="Times New Roman" panose="02020603050405020304" pitchFamily="18" charset="0"/>
                 <a:cs typeface="Times New Roman" panose="02020603050405020304" pitchFamily="18" charset="0"/>
               </a:rPr>
-              <a:t>05/10/26</a:t>
+              <a:t>25-10-2026</a:t>
             </a:fld>
             <a:endParaRPr lang="en-IN">
               <a:latin typeface="Times New Roman" panose="02020603050405020304" pitchFamily="18" charset="0"/>
@@ -8826,7 +8865,7 @@
           <p:cNvPr id="5" name="Footer Placeholder 4">
             <a:extLst>
               <a:ext uri="{FF2B5EF4-FFF2-40B4-BE49-F238E27FC236}">
-                <a16:creationId xmlns:a16="http://schemas.microsoft.com/office/drawing/2014/main" xmlns="" id="{5BCDC439-5940-84EE-247A-E3018795A431}"/>
+                <a16:creationId xmlns:a16="http://schemas.microsoft.com/office/drawing/2014/main" id="{5BCDC439-5940-84EE-247A-E3018795A431}"/>
               </a:ext>
             </a:extLst>
           </p:cNvPr>
@@ -8857,7 +8896,7 @@
           <p:cNvPr id="6" name="Slide Number Placeholder 5">
             <a:extLst>
               <a:ext uri="{FF2B5EF4-FFF2-40B4-BE49-F238E27FC236}">
-                <a16:creationId xmlns:a16="http://schemas.microsoft.com/office/drawing/2014/main" xmlns="" id="{A6CB23C8-7091-8CFB-BF2C-3A19CCA810FF}"/>
+                <a16:creationId xmlns:a16="http://schemas.microsoft.com/office/drawing/2014/main" id="{A6CB23C8-7091-8CFB-BF2C-3A19CCA810FF}"/>
               </a:ext>
             </a:extLst>
           </p:cNvPr>
@@ -8932,7 +8971,7 @@
         <p:cNvPr id="1" name="">
           <a:extLst>
             <a:ext uri="{FF2B5EF4-FFF2-40B4-BE49-F238E27FC236}">
-              <a16:creationId xmlns:a16="http://schemas.microsoft.com/office/drawing/2014/main" xmlns="" id="{7FE95AF1-B807-AC15-9C1A-B86677AF63DA}"/>
+              <a16:creationId xmlns:a16="http://schemas.microsoft.com/office/drawing/2014/main" id="{7FE95AF1-B807-AC15-9C1A-B86677AF63DA}"/>
             </a:ext>
           </a:extLst>
         </p:cNvPr>
@@ -8952,7 +8991,7 @@
           <p:cNvPr id="3" name="Content Placeholder 2">
             <a:extLst>
               <a:ext uri="{FF2B5EF4-FFF2-40B4-BE49-F238E27FC236}">
-                <a16:creationId xmlns:a16="http://schemas.microsoft.com/office/drawing/2014/main" xmlns="" id="{EEF324FF-B70A-2FC0-8FD0-C802E31DDBD0}"/>
+                <a16:creationId xmlns:a16="http://schemas.microsoft.com/office/drawing/2014/main" id="{EEF324FF-B70A-2FC0-8FD0-C802E31DDBD0}"/>
               </a:ext>
             </a:extLst>
           </p:cNvPr>
@@ -9156,7 +9195,7 @@
           <p:cNvPr id="4" name="object 2">
             <a:extLst>
               <a:ext uri="{FF2B5EF4-FFF2-40B4-BE49-F238E27FC236}">
-                <a16:creationId xmlns:a16="http://schemas.microsoft.com/office/drawing/2014/main" xmlns="" id="{0C9A0194-5820-F292-3A94-449C000E51A7}"/>
+                <a16:creationId xmlns:a16="http://schemas.microsoft.com/office/drawing/2014/main" id="{0C9A0194-5820-F292-3A94-449C000E51A7}"/>
               </a:ext>
             </a:extLst>
           </p:cNvPr>
@@ -9209,7 +9248,7 @@
           <p:cNvPr id="2" name="Date Placeholder 1">
             <a:extLst>
               <a:ext uri="{FF2B5EF4-FFF2-40B4-BE49-F238E27FC236}">
-                <a16:creationId xmlns:a16="http://schemas.microsoft.com/office/drawing/2014/main" xmlns="" id="{D4F25267-3005-EC45-A624-B78484DFA4EC}"/>
+                <a16:creationId xmlns:a16="http://schemas.microsoft.com/office/drawing/2014/main" id="{D4F25267-3005-EC45-A624-B78484DFA4EC}"/>
               </a:ext>
             </a:extLst>
           </p:cNvPr>
@@ -9230,7 +9269,7 @@
                 <a:latin typeface="Times New Roman" panose="02020603050405020304" pitchFamily="18" charset="0"/>
                 <a:cs typeface="Times New Roman" panose="02020603050405020304" pitchFamily="18" charset="0"/>
               </a:rPr>
-              <a:t>05/10/26</a:t>
+              <a:t>25-10-2026</a:t>
             </a:fld>
             <a:endParaRPr lang="en-IN">
               <a:latin typeface="Times New Roman" panose="02020603050405020304" pitchFamily="18" charset="0"/>
@@ -9244,7 +9283,7 @@
           <p:cNvPr id="5" name="Footer Placeholder 4">
             <a:extLst>
               <a:ext uri="{FF2B5EF4-FFF2-40B4-BE49-F238E27FC236}">
-                <a16:creationId xmlns:a16="http://schemas.microsoft.com/office/drawing/2014/main" xmlns="" id="{610022FF-AD0C-E15E-5F17-B2827B5546B1}"/>
+                <a16:creationId xmlns:a16="http://schemas.microsoft.com/office/drawing/2014/main" id="{610022FF-AD0C-E15E-5F17-B2827B5546B1}"/>
               </a:ext>
             </a:extLst>
           </p:cNvPr>
@@ -9275,7 +9314,7 @@
           <p:cNvPr id="6" name="Slide Number Placeholder 5">
             <a:extLst>
               <a:ext uri="{FF2B5EF4-FFF2-40B4-BE49-F238E27FC236}">
-                <a16:creationId xmlns:a16="http://schemas.microsoft.com/office/drawing/2014/main" xmlns="" id="{BD8D6198-8B2C-26FB-53D2-A5B87C95A4FB}"/>
+                <a16:creationId xmlns:a16="http://schemas.microsoft.com/office/drawing/2014/main" id="{BD8D6198-8B2C-26FB-53D2-A5B87C95A4FB}"/>
               </a:ext>
             </a:extLst>
           </p:cNvPr>
@@ -9607,7 +9646,7 @@
   <a:extraClrSchemeLst/>
   <a:extLst>
     <a:ext uri="{05A4C25C-085E-4340-85A3-A5531E510DB2}">
-      <thm15:themeFamily xmlns:thm15="http://schemas.microsoft.com/office/thememl/2012/main" xmlns="" name="Office Theme" id="{62F939B6-93AF-4DB8-9C6B-D6C7DFDC589F}" vid="{4A3C46E8-61CC-4603-A589-7422A47A8E4A}"/>
+      <thm15:themeFamily xmlns:thm15="http://schemas.microsoft.com/office/thememl/2012/main" name="Office Theme" id="{62F939B6-93AF-4DB8-9C6B-D6C7DFDC589F}" vid="{4A3C46E8-61CC-4603-A589-7422A47A8E4A}"/>
     </a:ext>
   </a:extLst>
 </a:theme>
@@ -9902,7 +9941,7 @@
   <a:extraClrSchemeLst/>
   <a:extLst>
     <a:ext uri="{05A4C25C-085E-4340-85A3-A5531E510DB2}">
-      <thm15:themeFamily xmlns:thm15="http://schemas.microsoft.com/office/thememl/2012/main" xmlns="" name="Office Theme" id="{62F939B6-93AF-4DB8-9C6B-D6C7DFDC589F}" vid="{4A3C46E8-61CC-4603-A589-7422A47A8E4A}"/>
+      <thm15:themeFamily xmlns:thm15="http://schemas.microsoft.com/office/thememl/2012/main" name="Office Theme" id="{62F939B6-93AF-4DB8-9C6B-D6C7DFDC589F}" vid="{4A3C46E8-61CC-4603-A589-7422A47A8E4A}"/>
     </a:ext>
   </a:extLst>
 </a:theme>

</xml_diff>